<commit_message>
Geschichte 11: Bild-Impuls mit Fehlersuche als Einstieg ins Bürgeramt
Co-Authored-By: Claude Opus 5.5 <noreply@anthropic.com>
Claude-Session: https://claude.ai/code/session_013iN4Tiarea1J9YUJHZ9iqC
</commit_message>
<xml_diff>
--- a/Geschichte_11/Stunde_Buergeramt_Athen/Folien_Buergeramt_Athen.pptx
+++ b/Geschichte_11/Stunde_Buergeramt_Athen/Folien_Buergeramt_Athen.pptx
@@ -12,9 +12,11 @@
     <p:sldId id="260" r:id="rId6"/>
     <p:sldId id="261" r:id="rId7"/>
     <p:sldId id="262" r:id="rId8"/>
+    <p:sldId id="263" r:id="rId9"/>
+    <p:sldId id="264" r:id="rId10"/>
   </p:sldIdLst>
   <p:notesMasterIdLst>
-    <p:notesMasterId r:id="rId9"/>
+    <p:notesMasterId r:id="rId11"/>
   </p:notesMasterIdLst>
   <p:sldSz cx="9144000" cy="5143500"/>
   <p:notesSz cx="5143500" cy="9144000"/>
@@ -596,7 +598,7 @@
           <a:p>
             <a:r>
               <a:rPr lang="en-US" dirty="0"/>
-              <a:t>0–2 Min. Pro Tisch ein Anliegen austeilen (Anliegen 1–9).</a:t>
+              <a:t>Bild wortlos zeigen. 1 Minute zu zweit Fehler suchen, dann auflösen (nächste Folie).</a:t>
             </a:r>
             <a:endParaRPr lang="en-US" dirty="0"/>
           </a:p>
@@ -684,7 +686,7 @@
           <a:p>
             <a:r>
               <a:rPr lang="en-US" dirty="0"/>
-              <a:t>2–12 Min. Herumgehen. Häufige Lücke: nur Ja/Nein ohne Organ oder Klasse. Nachfragen: Welche Klasse? Wer ist zuständig?</a:t>
+              <a:t>Bezug zu BM 1: Quelle oder Darstellung. Der Satz in der Sprechblase ist dagegen korrekt – das ist die Überleitung zum Bürgeramt.</a:t>
             </a:r>
             <a:endParaRPr lang="en-US" dirty="0"/>
           </a:p>
@@ -772,7 +774,7 @@
           <a:p>
             <a:r>
               <a:rPr lang="en-US" dirty="0"/>
-              <a:t>12–27 Min. Reihenfolge 1–9. Pro Anliegen ca. 1½ Min. Bei falscher Entscheidung nicht selbst korrigieren, sondern fragen: „Stimmt ihr zu? Schaut ins Schaubild.“ Die Folie kann auf das Whiteboard projiziert werden, sodass die Beamten direkt hineinschreiben.</a:t>
+              <a:t>4–5 Min. Pro Tisch ein Anliegen austeilen (Anliegen 1–9).</a:t>
             </a:r>
             <a:endParaRPr lang="en-US" dirty="0"/>
           </a:p>
@@ -860,7 +862,7 @@
           <a:p>
             <a:r>
               <a:rPr lang="en-US" dirty="0"/>
-              <a:t>27–29 Min. Selbstkontrolle der Ergebnistabelle. Kurzer Impuls zu 4 und 7: Der verarmte Adlige wird abgelehnt, der reiche Töpfersohn genehmigt – Besitz statt Herkunft.</a:t>
+              <a:t>2–12 Min. Herumgehen. Häufige Lücke: nur Ja/Nein ohne Organ oder Klasse. Nachfragen: Welche Klasse? Wer ist zuständig?</a:t>
             </a:r>
             <a:endParaRPr lang="en-US" dirty="0"/>
           </a:p>
@@ -948,7 +950,7 @@
           <a:p>
             <a:r>
               <a:rPr lang="en-US" dirty="0"/>
-              <a:t>29–36 Min. Erst danach die Lösung zeigen. Das Blatt kommt in den Hefter; eingesammelt zeigt es, wer das Schaubild verstanden hat.</a:t>
+              <a:t>12–27 Min. Reihenfolge 1–9. Pro Anliegen ca. 1½ Min. Bei falscher Entscheidung nicht selbst korrigieren, sondern fragen: „Stimmt ihr zu? Schaut ins Schaubild.“ Die Folie kann auf das Whiteboard projiziert werden, sodass die Beamten direkt hineinschreiben.</a:t>
             </a:r>
             <a:endParaRPr lang="en-US" dirty="0"/>
           </a:p>
@@ -1036,7 +1038,7 @@
           <a:p>
             <a:r>
               <a:rPr lang="en-US" dirty="0"/>
-              <a:t>36–39 Min. Selbstkontrolle, kein Plenum. Restzeit: Puffer – oder Sachurteil „War Solons Verfassung eher demokratisch oder timokratisch?“ als Hausaufgabe.</a:t>
+              <a:t>27–29 Min. Selbstkontrolle der Ergebnistabelle. Kurzer Impuls zu 4 und 7: Der verarmte Adlige wird abgelehnt, der reiche Töpfersohn genehmigt – Besitz statt Herkunft.</a:t>
             </a:r>
             <a:endParaRPr lang="en-US" dirty="0"/>
           </a:p>
@@ -1060,6 +1062,182 @@
             <a:fld id="{F7021451-1387-4CA6-816F-3879F97B5CBC}" type="slidenum">
               <a:rPr lang="en-US"/>
               <a:t>7</a:t>
+            </a:fld>
+            <a:endParaRPr lang="en-US"/>
+          </a:p>
+        </p:txBody>
+      </p:sp>
+    </p:spTree>
+    <p:extLst>
+      <p:ext uri="{BB962C8B-B14F-4D97-AF65-F5344CB8AC3E}">
+        <p14:creationId xmlns:p14="http://schemas.microsoft.com/office/powerpoint/2010/main" val="1024086991"/>
+      </p:ext>
+    </p:extLst>
+  </p:cSld>
+  <p:clrMapOvr>
+    <a:masterClrMapping/>
+  </p:clrMapOvr>
+</p:notes>
+</file>
+
+<file path=ppt/notesSlides/notesSlide8.xml><?xml version="1.0" encoding="utf-8"?>
+<p:notes xmlns:a="http://schemas.openxmlformats.org/drawingml/2006/main" xmlns:r="http://schemas.openxmlformats.org/officeDocument/2006/relationships" xmlns:p="http://schemas.openxmlformats.org/presentationml/2006/main">
+  <p:cSld>
+    <p:spTree>
+      <p:nvGrpSpPr>
+        <p:cNvPr id="1" name=""/>
+        <p:cNvGrpSpPr/>
+        <p:nvPr/>
+      </p:nvGrpSpPr>
+      <p:grpSpPr>
+        <a:xfrm>
+          <a:off x="0" y="0"/>
+          <a:ext cx="0" cy="0"/>
+          <a:chOff x="0" y="0"/>
+          <a:chExt cx="0" cy="0"/>
+        </a:xfrm>
+      </p:grpSpPr>
+      <p:sp>
+        <p:nvSpPr>
+          <p:cNvPr id="2" name="Slide Image Placeholder 1"/>
+          <p:cNvSpPr>
+            <a:spLocks noGrp="1" noRot="1" noChangeAspect="1"/>
+          </p:cNvSpPr>
+          <p:nvPr>
+            <p:ph type="sldImg"/>
+          </p:nvPr>
+        </p:nvSpPr>
+        <p:spPr/>
+      </p:sp>
+      <p:sp>
+        <p:nvSpPr>
+          <p:cNvPr id="3" name="Notes Placeholder 2"/>
+          <p:cNvSpPr>
+            <a:spLocks noGrp="1"/>
+          </p:cNvSpPr>
+          <p:nvPr>
+            <p:ph type="body" idx="1"/>
+          </p:nvPr>
+        </p:nvSpPr>
+        <p:spPr/>
+        <p:txBody>
+          <a:bodyPr/>
+          <a:lstStyle/>
+          <a:p>
+            <a:r>
+              <a:rPr lang="en-US" dirty="0"/>
+              <a:t>29–36 Min. Erst danach die Lösung zeigen. Das Blatt kommt in den Hefter; eingesammelt zeigt es, wer das Schaubild verstanden hat.</a:t>
+            </a:r>
+            <a:endParaRPr lang="en-US" dirty="0"/>
+          </a:p>
+        </p:txBody>
+      </p:sp>
+      <p:sp>
+        <p:nvSpPr>
+          <p:cNvPr id="4" name="Slide Number Placeholder 3"/>
+          <p:cNvSpPr>
+            <a:spLocks noGrp="1"/>
+          </p:cNvSpPr>
+          <p:nvPr>
+            <p:ph type="sldNum" sz="quarter" idx="10"/>
+          </p:nvPr>
+        </p:nvSpPr>
+        <p:spPr/>
+        <p:txBody>
+          <a:bodyPr/>
+          <a:lstStyle/>
+          <a:p>
+            <a:fld id="{F7021451-1387-4CA6-816F-3879F97B5CBC}" type="slidenum">
+              <a:rPr lang="en-US"/>
+              <a:t>8</a:t>
+            </a:fld>
+            <a:endParaRPr lang="en-US"/>
+          </a:p>
+        </p:txBody>
+      </p:sp>
+    </p:spTree>
+    <p:extLst>
+      <p:ext uri="{BB962C8B-B14F-4D97-AF65-F5344CB8AC3E}">
+        <p14:creationId xmlns:p14="http://schemas.microsoft.com/office/powerpoint/2010/main" val="1024086991"/>
+      </p:ext>
+    </p:extLst>
+  </p:cSld>
+  <p:clrMapOvr>
+    <a:masterClrMapping/>
+  </p:clrMapOvr>
+</p:notes>
+</file>
+
+<file path=ppt/notesSlides/notesSlide9.xml><?xml version="1.0" encoding="utf-8"?>
+<p:notes xmlns:a="http://schemas.openxmlformats.org/drawingml/2006/main" xmlns:r="http://schemas.openxmlformats.org/officeDocument/2006/relationships" xmlns:p="http://schemas.openxmlformats.org/presentationml/2006/main">
+  <p:cSld>
+    <p:spTree>
+      <p:nvGrpSpPr>
+        <p:cNvPr id="1" name=""/>
+        <p:cNvGrpSpPr/>
+        <p:nvPr/>
+      </p:nvGrpSpPr>
+      <p:grpSpPr>
+        <a:xfrm>
+          <a:off x="0" y="0"/>
+          <a:ext cx="0" cy="0"/>
+          <a:chOff x="0" y="0"/>
+          <a:chExt cx="0" cy="0"/>
+        </a:xfrm>
+      </p:grpSpPr>
+      <p:sp>
+        <p:nvSpPr>
+          <p:cNvPr id="2" name="Slide Image Placeholder 1"/>
+          <p:cNvSpPr>
+            <a:spLocks noGrp="1" noRot="1" noChangeAspect="1"/>
+          </p:cNvSpPr>
+          <p:nvPr>
+            <p:ph type="sldImg"/>
+          </p:nvPr>
+        </p:nvSpPr>
+        <p:spPr/>
+      </p:sp>
+      <p:sp>
+        <p:nvSpPr>
+          <p:cNvPr id="3" name="Notes Placeholder 2"/>
+          <p:cNvSpPr>
+            <a:spLocks noGrp="1"/>
+          </p:cNvSpPr>
+          <p:nvPr>
+            <p:ph type="body" idx="1"/>
+          </p:nvPr>
+        </p:nvSpPr>
+        <p:spPr/>
+        <p:txBody>
+          <a:bodyPr/>
+          <a:lstStyle/>
+          <a:p>
+            <a:r>
+              <a:rPr lang="en-US" dirty="0"/>
+              <a:t>36–39 Min. Selbstkontrolle, kein Plenum. Restzeit: Puffer – oder Sachurteil „War Solons Verfassung eher demokratisch oder timokratisch?“ als Hausaufgabe.</a:t>
+            </a:r>
+            <a:endParaRPr lang="en-US" dirty="0"/>
+          </a:p>
+        </p:txBody>
+      </p:sp>
+      <p:sp>
+        <p:nvSpPr>
+          <p:cNvPr id="4" name="Slide Number Placeholder 3"/>
+          <p:cNvSpPr>
+            <a:spLocks noGrp="1"/>
+          </p:cNvSpPr>
+          <p:nvPr>
+            <p:ph type="sldNum" sz="quarter" idx="10"/>
+          </p:nvPr>
+        </p:nvSpPr>
+        <p:spPr/>
+        <p:txBody>
+          <a:bodyPr/>
+          <a:lstStyle/>
+          <a:p>
+            <a:fld id="{F7021451-1387-4CA6-816F-3879F97B5CBC}" type="slidenum">
+              <a:rPr lang="en-US"/>
+              <a:t>9</a:t>
             </a:fld>
             <a:endParaRPr lang="en-US"/>
           </a:p>
@@ -1540,6 +1718,849 @@
     <p:bg>
       <p:bgPr>
         <a:solidFill>
+          <a:srgbClr val="F4ECDE"/>
+        </a:solidFill>
+      </p:bgPr>
+    </p:bg>
+    <p:spTree>
+      <p:nvGrpSpPr>
+        <p:cNvPr id="1" name=""/>
+        <p:cNvGrpSpPr/>
+        <p:nvPr/>
+      </p:nvGrpSpPr>
+      <p:grpSpPr>
+        <a:xfrm>
+          <a:off x="0" y="0"/>
+          <a:ext cx="0" cy="0"/>
+          <a:chOff x="0" y="0"/>
+          <a:chExt cx="0" cy="0"/>
+        </a:xfrm>
+      </p:grpSpPr>
+      <p:pic>
+        <p:nvPicPr>
+          <p:cNvPr id="2" name="Image 0" descr="/tmp/claude-0/-home-user-Schule/9be99485-7769-5631-81b2-1e426720ceab/scratchpad/beamtin.png">    </p:cNvPr>
+          <p:cNvPicPr>
+            <a:picLocks noChangeAspect="1"/>
+          </p:cNvPicPr>
+          <p:nvPr/>
+        </p:nvPicPr>
+        <p:blipFill>
+          <a:blip r:embed="rId1"/>
+          <a:stretch>
+            <a:fillRect/>
+          </a:stretch>
+        </p:blipFill>
+        <p:spPr>
+          <a:xfrm>
+            <a:off x="914400" y="0"/>
+            <a:ext cx="7315200" cy="4572000"/>
+          </a:xfrm>
+          <a:prstGeom prst="rect">
+            <a:avLst/>
+          </a:prstGeom>
+        </p:spPr>
+      </p:pic>
+      <p:sp>
+        <p:nvSpPr>
+          <p:cNvPr id="3" name="Shape 0"/>
+          <p:cNvSpPr/>
+          <p:nvPr/>
+        </p:nvSpPr>
+        <p:spPr>
+          <a:xfrm>
+            <a:off x="0" y="4572000"/>
+            <a:ext cx="9144000" cy="571500"/>
+          </a:xfrm>
+          <a:prstGeom prst="roundRect">
+            <a:avLst>
+              <a:gd name="adj" fmla="val 12800"/>
+            </a:avLst>
+          </a:prstGeom>
+          <a:solidFill>
+            <a:srgbClr val="2B2318"/>
+          </a:solidFill>
+          <a:ln w="12700">
+            <a:solidFill>
+              <a:srgbClr val="2B2318"/>
+            </a:solidFill>
+            <a:prstDash val="solid"/>
+          </a:ln>
+        </p:spPr>
+      </p:sp>
+      <p:sp>
+        <p:nvSpPr>
+          <p:cNvPr id="4" name="Text 1"/>
+          <p:cNvSpPr txBox="1"/>
+          <p:nvPr/>
+        </p:nvSpPr>
+        <p:spPr>
+          <a:xfrm>
+            <a:off x="365760" y="4572000"/>
+            <a:ext cx="6949440" cy="571500"/>
+          </a:xfrm>
+          <a:prstGeom prst="rect">
+            <a:avLst/>
+          </a:prstGeom>
+          <a:noFill/>
+          <a:ln/>
+        </p:spPr>
+        <p:txBody>
+          <a:bodyPr wrap="square" lIns="0" tIns="0" rIns="0" bIns="0" rtlCol="0" anchor="ctr"/>
+          <a:lstStyle/>
+          <a:p>
+            <a:pPr indent="0" marL="0">
+              <a:buNone/>
+            </a:pPr>
+            <a:r>
+              <a:rPr lang="en-US" sz="1800" b="1" dirty="0">
+                <a:solidFill>
+                  <a:srgbClr val="D9A441"/>
+                </a:solidFill>
+                <a:latin typeface="Calibri" pitchFamily="34" charset="0"/>
+                <a:ea typeface="Calibri" pitchFamily="34" charset="-122"/>
+                <a:cs typeface="Calibri" pitchFamily="34" charset="-120"/>
+              </a:rPr>
+              <a:t>Was stimmt an diesem Bild nicht? Findet drei Fehler.</a:t>
+            </a:r>
+            <a:endParaRPr lang="en-US" sz="1800" dirty="0"/>
+          </a:p>
+        </p:txBody>
+      </p:sp>
+      <p:sp>
+        <p:nvSpPr>
+          <p:cNvPr id="5" name="Text 2"/>
+          <p:cNvSpPr txBox="1"/>
+          <p:nvPr/>
+        </p:nvSpPr>
+        <p:spPr>
+          <a:xfrm>
+            <a:off x="7589520" y="4700016"/>
+            <a:ext cx="1188720" cy="310896"/>
+          </a:xfrm>
+          <a:prstGeom prst="roundRect">
+            <a:avLst>
+              <a:gd name="adj" fmla="val 29412"/>
+            </a:avLst>
+          </a:prstGeom>
+          <a:solidFill>
+            <a:srgbClr val="D9A441"/>
+          </a:solidFill>
+          <a:ln/>
+        </p:spPr>
+        <p:txBody>
+          <a:bodyPr wrap="square" lIns="25400" tIns="25400" rIns="25400" bIns="25400" rtlCol="0" anchor="ctr"/>
+          <a:lstStyle/>
+          <a:p>
+            <a:pPr algn="ctr" indent="0" marL="0">
+              <a:buNone/>
+            </a:pPr>
+            <a:r>
+              <a:rPr lang="en-US" sz="1100" b="1" dirty="0">
+                <a:solidFill>
+                  <a:srgbClr val="2B2318"/>
+                </a:solidFill>
+                <a:latin typeface="Calibri" pitchFamily="34" charset="0"/>
+                <a:ea typeface="Calibri" pitchFamily="34" charset="-122"/>
+                <a:cs typeface="Calibri" pitchFamily="34" charset="-120"/>
+              </a:rPr>
+              <a:t>2 Min.</a:t>
+            </a:r>
+            <a:endParaRPr lang="en-US" sz="1100" dirty="0"/>
+          </a:p>
+        </p:txBody>
+      </p:sp>
+    </p:spTree>
+  </p:cSld>
+  <p:clrMapOvr>
+    <a:masterClrMapping/>
+  </p:clrMapOvr>
+</p:sld>
+</file>
+
+<file path=ppt/slides/slide3.xml><?xml version="1.0" encoding="utf-8"?>
+<p:sld xmlns:a="http://schemas.openxmlformats.org/drawingml/2006/main" xmlns:r="http://schemas.openxmlformats.org/officeDocument/2006/relationships" xmlns:p="http://schemas.openxmlformats.org/presentationml/2006/main">
+  <p:cSld name="Slide 3">
+    <p:bg>
+      <p:bgPr>
+        <a:solidFill>
+          <a:srgbClr val="FFFFFF"/>
+        </a:solidFill>
+      </p:bgPr>
+    </p:bg>
+    <p:spTree>
+      <p:nvGrpSpPr>
+        <p:cNvPr id="1" name=""/>
+        <p:cNvGrpSpPr/>
+        <p:nvPr/>
+      </p:nvGrpSpPr>
+      <p:grpSpPr>
+        <a:xfrm>
+          <a:off x="0" y="0"/>
+          <a:ext cx="0" cy="0"/>
+          <a:chOff x="0" y="0"/>
+          <a:chExt cx="0" cy="0"/>
+        </a:xfrm>
+      </p:grpSpPr>
+      <p:sp>
+        <p:nvSpPr>
+          <p:cNvPr id="2" name="Text 0"/>
+          <p:cNvSpPr txBox="1"/>
+          <p:nvPr/>
+        </p:nvSpPr>
+        <p:spPr>
+          <a:xfrm>
+            <a:off x="457200" y="320040"/>
+            <a:ext cx="6766560" cy="228600"/>
+          </a:xfrm>
+          <a:prstGeom prst="rect">
+            <a:avLst/>
+          </a:prstGeom>
+          <a:noFill/>
+          <a:ln/>
+        </p:spPr>
+        <p:txBody>
+          <a:bodyPr wrap="square" lIns="0" tIns="0" rIns="0" bIns="0" rtlCol="0" anchor="t"/>
+          <a:lstStyle/>
+          <a:p>
+            <a:pPr indent="0" marL="0">
+              <a:buNone/>
+            </a:pPr>
+            <a:r>
+              <a:rPr lang="en-US" sz="1100" b="1" spc="200" kern="0" dirty="0">
+                <a:solidFill>
+                  <a:srgbClr val="AD4426"/>
+                </a:solidFill>
+                <a:latin typeface="Calibri" pitchFamily="34" charset="0"/>
+                <a:ea typeface="Calibri" pitchFamily="34" charset="-122"/>
+                <a:cs typeface="Calibri" pitchFamily="34" charset="-120"/>
+              </a:rPr>
+              <a:t>AUFLÖSUNG</a:t>
+            </a:r>
+            <a:endParaRPr lang="en-US" sz="1100" dirty="0"/>
+          </a:p>
+        </p:txBody>
+      </p:sp>
+      <p:sp>
+        <p:nvSpPr>
+          <p:cNvPr id="3" name="Text 1"/>
+          <p:cNvSpPr txBox="1"/>
+          <p:nvPr/>
+        </p:nvSpPr>
+        <p:spPr>
+          <a:xfrm>
+            <a:off x="457200" y="548640"/>
+            <a:ext cx="8229600" cy="594360"/>
+          </a:xfrm>
+          <a:prstGeom prst="rect">
+            <a:avLst/>
+          </a:prstGeom>
+          <a:noFill/>
+          <a:ln/>
+        </p:spPr>
+        <p:txBody>
+          <a:bodyPr wrap="square" lIns="0" tIns="0" rIns="0" bIns="0" rtlCol="0" anchor="t"/>
+          <a:lstStyle/>
+          <a:p>
+            <a:pPr indent="0" marL="0">
+              <a:buNone/>
+            </a:pPr>
+            <a:r>
+              <a:rPr lang="en-US" sz="2800" b="1" dirty="0">
+                <a:solidFill>
+                  <a:srgbClr val="2B2318"/>
+                </a:solidFill>
+                <a:latin typeface="Cambria" pitchFamily="34" charset="0"/>
+                <a:ea typeface="Cambria" pitchFamily="34" charset="-122"/>
+                <a:cs typeface="Cambria" pitchFamily="34" charset="-120"/>
+              </a:rPr>
+              <a:t>Drei Fehler im Bild</a:t>
+            </a:r>
+            <a:endParaRPr lang="en-US" sz="2800" dirty="0"/>
+          </a:p>
+        </p:txBody>
+      </p:sp>
+      <p:sp>
+        <p:nvSpPr>
+          <p:cNvPr id="4" name="Text 2"/>
+          <p:cNvSpPr txBox="1"/>
+          <p:nvPr/>
+        </p:nvSpPr>
+        <p:spPr>
+          <a:xfrm>
+            <a:off x="7315200" y="347472"/>
+            <a:ext cx="1371600" cy="292608"/>
+          </a:xfrm>
+          <a:prstGeom prst="roundRect">
+            <a:avLst>
+              <a:gd name="adj" fmla="val 31250"/>
+            </a:avLst>
+          </a:prstGeom>
+          <a:solidFill>
+            <a:srgbClr val="D9A441"/>
+          </a:solidFill>
+          <a:ln/>
+        </p:spPr>
+        <p:txBody>
+          <a:bodyPr wrap="square" lIns="25400" tIns="25400" rIns="25400" bIns="25400" rtlCol="0" anchor="ctr"/>
+          <a:lstStyle/>
+          <a:p>
+            <a:pPr algn="ctr" indent="0" marL="0">
+              <a:buNone/>
+            </a:pPr>
+            <a:r>
+              <a:rPr lang="en-US" sz="1100" b="1" dirty="0">
+                <a:solidFill>
+                  <a:srgbClr val="2B2318"/>
+                </a:solidFill>
+                <a:latin typeface="Calibri" pitchFamily="34" charset="0"/>
+                <a:ea typeface="Calibri" pitchFamily="34" charset="-122"/>
+                <a:cs typeface="Calibri" pitchFamily="34" charset="-120"/>
+              </a:rPr>
+              <a:t>Auflösung</a:t>
+            </a:r>
+            <a:endParaRPr lang="en-US" sz="1100" dirty="0"/>
+          </a:p>
+        </p:txBody>
+      </p:sp>
+      <p:pic>
+        <p:nvPicPr>
+          <p:cNvPr id="5" name="Image 0" descr="/tmp/claude-0/-home-user-Schule/9be99485-7769-5631-81b2-1e426720ceab/scratchpad/beamtin.png">    </p:cNvPr>
+          <p:cNvPicPr>
+            <a:picLocks noChangeAspect="1"/>
+          </p:cNvPicPr>
+          <p:nvPr/>
+        </p:nvPicPr>
+        <p:blipFill>
+          <a:blip r:embed="rId1"/>
+          <a:stretch>
+            <a:fillRect/>
+          </a:stretch>
+        </p:blipFill>
+        <p:spPr>
+          <a:xfrm>
+            <a:off x="457200" y="1234440"/>
+            <a:ext cx="4206240" cy="2628900"/>
+          </a:xfrm>
+          <a:prstGeom prst="rect">
+            <a:avLst/>
+          </a:prstGeom>
+        </p:spPr>
+      </p:pic>
+      <p:sp>
+        <p:nvSpPr>
+          <p:cNvPr id="6" name="Text 3"/>
+          <p:cNvSpPr txBox="1"/>
+          <p:nvPr/>
+        </p:nvSpPr>
+        <p:spPr>
+          <a:xfrm>
+            <a:off x="4892040" y="1325880"/>
+            <a:ext cx="457200" cy="457200"/>
+          </a:xfrm>
+          <a:prstGeom prst="ellipse">
+            <a:avLst/>
+          </a:prstGeom>
+          <a:solidFill>
+            <a:srgbClr val="AD4426"/>
+          </a:solidFill>
+          <a:ln/>
+        </p:spPr>
+        <p:txBody>
+          <a:bodyPr wrap="square" lIns="0" tIns="0" rIns="0" bIns="0" rtlCol="0" anchor="ctr"/>
+          <a:lstStyle/>
+          <a:p>
+            <a:pPr algn="ctr" indent="0" marL="0">
+              <a:buNone/>
+            </a:pPr>
+            <a:r>
+              <a:rPr lang="en-US" sz="1800" b="1" dirty="0">
+                <a:solidFill>
+                  <a:srgbClr val="FFFFFF"/>
+                </a:solidFill>
+                <a:latin typeface="Cambria" pitchFamily="34" charset="0"/>
+                <a:ea typeface="Cambria" pitchFamily="34" charset="-122"/>
+                <a:cs typeface="Cambria" pitchFamily="34" charset="-120"/>
+              </a:rPr>
+              <a:t>1</a:t>
+            </a:r>
+            <a:endParaRPr lang="en-US" sz="1800" dirty="0"/>
+          </a:p>
+        </p:txBody>
+      </p:sp>
+      <p:sp>
+        <p:nvSpPr>
+          <p:cNvPr id="7" name="Text 4"/>
+          <p:cNvSpPr txBox="1"/>
+          <p:nvPr/>
+        </p:nvSpPr>
+        <p:spPr>
+          <a:xfrm>
+            <a:off x="5486400" y="1252728"/>
+            <a:ext cx="3200400" cy="320040"/>
+          </a:xfrm>
+          <a:prstGeom prst="rect">
+            <a:avLst/>
+          </a:prstGeom>
+          <a:noFill/>
+          <a:ln/>
+        </p:spPr>
+        <p:txBody>
+          <a:bodyPr wrap="square" lIns="0" tIns="0" rIns="0" bIns="0" rtlCol="0" anchor="t"/>
+          <a:lstStyle/>
+          <a:p>
+            <a:pPr indent="0" marL="0">
+              <a:buNone/>
+            </a:pPr>
+            <a:r>
+              <a:rPr lang="en-US" sz="1500" b="1" dirty="0">
+                <a:solidFill>
+                  <a:srgbClr val="2B2318"/>
+                </a:solidFill>
+                <a:latin typeface="Cambria" pitchFamily="34" charset="0"/>
+                <a:ea typeface="Cambria" pitchFamily="34" charset="-122"/>
+                <a:cs typeface="Cambria" pitchFamily="34" charset="-120"/>
+              </a:rPr>
+              <a:t>Eine Frau als Beamtin</a:t>
+            </a:r>
+            <a:endParaRPr lang="en-US" sz="1500" dirty="0"/>
+          </a:p>
+        </p:txBody>
+      </p:sp>
+      <p:sp>
+        <p:nvSpPr>
+          <p:cNvPr id="8" name="Text 5"/>
+          <p:cNvSpPr txBox="1"/>
+          <p:nvPr/>
+        </p:nvSpPr>
+        <p:spPr>
+          <a:xfrm>
+            <a:off x="5486400" y="1600200"/>
+            <a:ext cx="3200400" cy="502920"/>
+          </a:xfrm>
+          <a:prstGeom prst="rect">
+            <a:avLst/>
+          </a:prstGeom>
+          <a:noFill/>
+          <a:ln/>
+        </p:spPr>
+        <p:txBody>
+          <a:bodyPr wrap="square" lIns="0" tIns="0" rIns="0" bIns="0" rtlCol="0" anchor="t"/>
+          <a:lstStyle/>
+          <a:p>
+            <a:pPr indent="0" marL="0">
+              <a:buNone/>
+            </a:pPr>
+            <a:r>
+              <a:rPr lang="en-US" sz="1200" dirty="0">
+                <a:solidFill>
+                  <a:srgbClr val="5A5044"/>
+                </a:solidFill>
+                <a:latin typeface="Calibri" pitchFamily="34" charset="0"/>
+                <a:ea typeface="Calibri" pitchFamily="34" charset="-122"/>
+                <a:cs typeface="Calibri" pitchFamily="34" charset="-120"/>
+              </a:rPr>
+              <a:t>Frauen hatten in Athen keine Ämter und keine politischen Rechte.</a:t>
+            </a:r>
+            <a:endParaRPr lang="en-US" sz="1200" dirty="0"/>
+          </a:p>
+        </p:txBody>
+      </p:sp>
+      <p:sp>
+        <p:nvSpPr>
+          <p:cNvPr id="9" name="Text 6"/>
+          <p:cNvSpPr txBox="1"/>
+          <p:nvPr/>
+        </p:nvSpPr>
+        <p:spPr>
+          <a:xfrm>
+            <a:off x="4892040" y="2240280"/>
+            <a:ext cx="457200" cy="457200"/>
+          </a:xfrm>
+          <a:prstGeom prst="ellipse">
+            <a:avLst/>
+          </a:prstGeom>
+          <a:solidFill>
+            <a:srgbClr val="AD4426"/>
+          </a:solidFill>
+          <a:ln/>
+        </p:spPr>
+        <p:txBody>
+          <a:bodyPr wrap="square" lIns="0" tIns="0" rIns="0" bIns="0" rtlCol="0" anchor="ctr"/>
+          <a:lstStyle/>
+          <a:p>
+            <a:pPr algn="ctr" indent="0" marL="0">
+              <a:buNone/>
+            </a:pPr>
+            <a:r>
+              <a:rPr lang="en-US" sz="1800" b="1" dirty="0">
+                <a:solidFill>
+                  <a:srgbClr val="FFFFFF"/>
+                </a:solidFill>
+                <a:latin typeface="Cambria" pitchFamily="34" charset="0"/>
+                <a:ea typeface="Cambria" pitchFamily="34" charset="-122"/>
+                <a:cs typeface="Cambria" pitchFamily="34" charset="-120"/>
+              </a:rPr>
+              <a:t>2</a:t>
+            </a:r>
+            <a:endParaRPr lang="en-US" sz="1800" dirty="0"/>
+          </a:p>
+        </p:txBody>
+      </p:sp>
+      <p:sp>
+        <p:nvSpPr>
+          <p:cNvPr id="10" name="Text 7"/>
+          <p:cNvSpPr txBox="1"/>
+          <p:nvPr/>
+        </p:nvSpPr>
+        <p:spPr>
+          <a:xfrm>
+            <a:off x="5486400" y="2167128"/>
+            <a:ext cx="3200400" cy="320040"/>
+          </a:xfrm>
+          <a:prstGeom prst="rect">
+            <a:avLst/>
+          </a:prstGeom>
+          <a:noFill/>
+          <a:ln/>
+        </p:spPr>
+        <p:txBody>
+          <a:bodyPr wrap="square" lIns="0" tIns="0" rIns="0" bIns="0" rtlCol="0" anchor="t"/>
+          <a:lstStyle/>
+          <a:p>
+            <a:pPr indent="0" marL="0">
+              <a:buNone/>
+            </a:pPr>
+            <a:r>
+              <a:rPr lang="en-US" sz="1500" b="1" dirty="0">
+                <a:solidFill>
+                  <a:srgbClr val="2B2318"/>
+                </a:solidFill>
+                <a:latin typeface="Cambria" pitchFamily="34" charset="0"/>
+                <a:ea typeface="Cambria" pitchFamily="34" charset="-122"/>
+                <a:cs typeface="Cambria" pitchFamily="34" charset="-120"/>
+              </a:rPr>
+              <a:t>Die Brille</a:t>
+            </a:r>
+            <a:endParaRPr lang="en-US" sz="1500" dirty="0"/>
+          </a:p>
+        </p:txBody>
+      </p:sp>
+      <p:sp>
+        <p:nvSpPr>
+          <p:cNvPr id="11" name="Text 8"/>
+          <p:cNvSpPr txBox="1"/>
+          <p:nvPr/>
+        </p:nvSpPr>
+        <p:spPr>
+          <a:xfrm>
+            <a:off x="5486400" y="2514600"/>
+            <a:ext cx="3200400" cy="502920"/>
+          </a:xfrm>
+          <a:prstGeom prst="rect">
+            <a:avLst/>
+          </a:prstGeom>
+          <a:noFill/>
+          <a:ln/>
+        </p:spPr>
+        <p:txBody>
+          <a:bodyPr wrap="square" lIns="0" tIns="0" rIns="0" bIns="0" rtlCol="0" anchor="t"/>
+          <a:lstStyle/>
+          <a:p>
+            <a:pPr indent="0" marL="0">
+              <a:buNone/>
+            </a:pPr>
+            <a:r>
+              <a:rPr lang="en-US" sz="1200" dirty="0">
+                <a:solidFill>
+                  <a:srgbClr val="5A5044"/>
+                </a:solidFill>
+                <a:latin typeface="Calibri" pitchFamily="34" charset="0"/>
+                <a:ea typeface="Calibri" pitchFamily="34" charset="-122"/>
+                <a:cs typeface="Calibri" pitchFamily="34" charset="-120"/>
+              </a:rPr>
+              <a:t>Brillen gibt es erst seit dem Mittelalter (13. Jh.).</a:t>
+            </a:r>
+            <a:endParaRPr lang="en-US" sz="1200" dirty="0"/>
+          </a:p>
+        </p:txBody>
+      </p:sp>
+      <p:sp>
+        <p:nvSpPr>
+          <p:cNvPr id="12" name="Text 9"/>
+          <p:cNvSpPr txBox="1"/>
+          <p:nvPr/>
+        </p:nvSpPr>
+        <p:spPr>
+          <a:xfrm>
+            <a:off x="4892040" y="3154680"/>
+            <a:ext cx="457200" cy="457200"/>
+          </a:xfrm>
+          <a:prstGeom prst="ellipse">
+            <a:avLst/>
+          </a:prstGeom>
+          <a:solidFill>
+            <a:srgbClr val="AD4426"/>
+          </a:solidFill>
+          <a:ln/>
+        </p:spPr>
+        <p:txBody>
+          <a:bodyPr wrap="square" lIns="0" tIns="0" rIns="0" bIns="0" rtlCol="0" anchor="ctr"/>
+          <a:lstStyle/>
+          <a:p>
+            <a:pPr algn="ctr" indent="0" marL="0">
+              <a:buNone/>
+            </a:pPr>
+            <a:r>
+              <a:rPr lang="en-US" sz="1800" b="1" dirty="0">
+                <a:solidFill>
+                  <a:srgbClr val="FFFFFF"/>
+                </a:solidFill>
+                <a:latin typeface="Cambria" pitchFamily="34" charset="0"/>
+                <a:ea typeface="Cambria" pitchFamily="34" charset="-122"/>
+                <a:cs typeface="Cambria" pitchFamily="34" charset="-120"/>
+              </a:rPr>
+              <a:t>3</a:t>
+            </a:r>
+            <a:endParaRPr lang="en-US" sz="1800" dirty="0"/>
+          </a:p>
+        </p:txBody>
+      </p:sp>
+      <p:sp>
+        <p:nvSpPr>
+          <p:cNvPr id="13" name="Text 10"/>
+          <p:cNvSpPr txBox="1"/>
+          <p:nvPr/>
+        </p:nvSpPr>
+        <p:spPr>
+          <a:xfrm>
+            <a:off x="5486400" y="3081528"/>
+            <a:ext cx="3200400" cy="320040"/>
+          </a:xfrm>
+          <a:prstGeom prst="rect">
+            <a:avLst/>
+          </a:prstGeom>
+          <a:noFill/>
+          <a:ln/>
+        </p:spPr>
+        <p:txBody>
+          <a:bodyPr wrap="square" lIns="0" tIns="0" rIns="0" bIns="0" rtlCol="0" anchor="t"/>
+          <a:lstStyle/>
+          <a:p>
+            <a:pPr indent="0" marL="0">
+              <a:buNone/>
+            </a:pPr>
+            <a:r>
+              <a:rPr lang="en-US" sz="1500" b="1" dirty="0">
+                <a:solidFill>
+                  <a:srgbClr val="2B2318"/>
+                </a:solidFill>
+                <a:latin typeface="Cambria" pitchFamily="34" charset="0"/>
+                <a:ea typeface="Cambria" pitchFamily="34" charset="-122"/>
+                <a:cs typeface="Cambria" pitchFamily="34" charset="-120"/>
+              </a:rPr>
+              <a:t>Der Kaffee</a:t>
+            </a:r>
+            <a:endParaRPr lang="en-US" sz="1500" dirty="0"/>
+          </a:p>
+        </p:txBody>
+      </p:sp>
+      <p:sp>
+        <p:nvSpPr>
+          <p:cNvPr id="14" name="Text 11"/>
+          <p:cNvSpPr txBox="1"/>
+          <p:nvPr/>
+        </p:nvSpPr>
+        <p:spPr>
+          <a:xfrm>
+            <a:off x="5486400" y="3429000"/>
+            <a:ext cx="3200400" cy="502920"/>
+          </a:xfrm>
+          <a:prstGeom prst="rect">
+            <a:avLst/>
+          </a:prstGeom>
+          <a:noFill/>
+          <a:ln/>
+        </p:spPr>
+        <p:txBody>
+          <a:bodyPr wrap="square" lIns="0" tIns="0" rIns="0" bIns="0" rtlCol="0" anchor="t"/>
+          <a:lstStyle/>
+          <a:p>
+            <a:pPr indent="0" marL="0">
+              <a:buNone/>
+            </a:pPr>
+            <a:r>
+              <a:rPr lang="en-US" sz="1200" dirty="0">
+                <a:solidFill>
+                  <a:srgbClr val="5A5044"/>
+                </a:solidFill>
+                <a:latin typeface="Calibri" pitchFamily="34" charset="0"/>
+                <a:ea typeface="Calibri" pitchFamily="34" charset="-122"/>
+                <a:cs typeface="Calibri" pitchFamily="34" charset="-120"/>
+              </a:rPr>
+              <a:t>Kaffee kam erst im 17. Jahrhundert nach Europa.</a:t>
+            </a:r>
+            <a:endParaRPr lang="en-US" sz="1200" dirty="0"/>
+          </a:p>
+        </p:txBody>
+      </p:sp>
+      <p:sp>
+        <p:nvSpPr>
+          <p:cNvPr id="15" name="Shape 12"/>
+          <p:cNvSpPr/>
+          <p:nvPr/>
+        </p:nvSpPr>
+        <p:spPr>
+          <a:xfrm>
+            <a:off x="457200" y="4069080"/>
+            <a:ext cx="8229600" cy="502920"/>
+          </a:xfrm>
+          <a:prstGeom prst="roundRect">
+            <a:avLst>
+              <a:gd name="adj" fmla="val 14545"/>
+            </a:avLst>
+          </a:prstGeom>
+          <a:solidFill>
+            <a:srgbClr val="2B2318"/>
+          </a:solidFill>
+          <a:ln w="12700">
+            <a:solidFill>
+              <a:srgbClr val="2B2318"/>
+            </a:solidFill>
+            <a:prstDash val="solid"/>
+          </a:ln>
+        </p:spPr>
+      </p:sp>
+      <p:sp>
+        <p:nvSpPr>
+          <p:cNvPr id="16" name="Text 13"/>
+          <p:cNvSpPr txBox="1"/>
+          <p:nvPr/>
+        </p:nvSpPr>
+        <p:spPr>
+          <a:xfrm>
+            <a:off x="640080" y="4069080"/>
+            <a:ext cx="7863840" cy="502920"/>
+          </a:xfrm>
+          <a:prstGeom prst="rect">
+            <a:avLst/>
+          </a:prstGeom>
+          <a:noFill/>
+          <a:ln/>
+        </p:spPr>
+        <p:txBody>
+          <a:bodyPr wrap="square" lIns="0" tIns="0" rIns="0" bIns="0" rtlCol="0" anchor="ctr"/>
+          <a:lstStyle/>
+          <a:p>
+            <a:pPr indent="0" marL="0">
+              <a:buNone/>
+            </a:pPr>
+            <a:r>
+              <a:rPr lang="en-US" sz="1250" b="1" dirty="0">
+                <a:solidFill>
+                  <a:srgbClr val="FFFFFF"/>
+                </a:solidFill>
+                <a:latin typeface="Calibri" pitchFamily="34" charset="0"/>
+                <a:ea typeface="Calibri" pitchFamily="34" charset="-122"/>
+                <a:cs typeface="Calibri" pitchFamily="34" charset="-120"/>
+              </a:rPr>
+              <a:t>Ein Bild ist eine Darstellung, keine Quelle – es kann sich irren. Was aber stimmt: Seit Solon zählt der Besitz.</a:t>
+            </a:r>
+            <a:endParaRPr lang="en-US" sz="1250" dirty="0"/>
+          </a:p>
+        </p:txBody>
+      </p:sp>
+      <p:sp>
+        <p:nvSpPr>
+          <p:cNvPr id="17" name="Text 14"/>
+          <p:cNvSpPr txBox="1"/>
+          <p:nvPr/>
+        </p:nvSpPr>
+        <p:spPr>
+          <a:xfrm>
+            <a:off x="457200" y="4754880"/>
+            <a:ext cx="4572000" cy="182880"/>
+          </a:xfrm>
+          <a:prstGeom prst="rect">
+            <a:avLst/>
+          </a:prstGeom>
+          <a:noFill/>
+          <a:ln/>
+        </p:spPr>
+        <p:txBody>
+          <a:bodyPr wrap="square" lIns="0" tIns="0" rIns="0" bIns="0" rtlCol="0" anchor="t"/>
+          <a:lstStyle/>
+          <a:p>
+            <a:pPr indent="0" marL="0">
+              <a:buNone/>
+            </a:pPr>
+            <a:r>
+              <a:rPr lang="en-US" sz="900" dirty="0">
+                <a:solidFill>
+                  <a:srgbClr val="998C77"/>
+                </a:solidFill>
+                <a:latin typeface="Calibri" pitchFamily="34" charset="0"/>
+                <a:ea typeface="Calibri" pitchFamily="34" charset="-122"/>
+                <a:cs typeface="Calibri" pitchFamily="34" charset="-120"/>
+              </a:rPr>
+              <a:t>Bürgeramt Athen</a:t>
+            </a:r>
+            <a:endParaRPr lang="en-US" sz="900" dirty="0"/>
+          </a:p>
+        </p:txBody>
+      </p:sp>
+      <p:sp>
+        <p:nvSpPr>
+          <p:cNvPr id="18" name="Text 15"/>
+          <p:cNvSpPr txBox="1"/>
+          <p:nvPr/>
+        </p:nvSpPr>
+        <p:spPr>
+          <a:xfrm>
+            <a:off x="8229600" y="4754880"/>
+            <a:ext cx="457200" cy="182880"/>
+          </a:xfrm>
+          <a:prstGeom prst="rect">
+            <a:avLst/>
+          </a:prstGeom>
+          <a:noFill/>
+          <a:ln/>
+        </p:spPr>
+        <p:txBody>
+          <a:bodyPr wrap="square" lIns="0" tIns="0" rIns="0" bIns="0" rtlCol="0" anchor="t"/>
+          <a:lstStyle/>
+          <a:p>
+            <a:pPr algn="r" indent="0" marL="0">
+              <a:buNone/>
+            </a:pPr>
+            <a:r>
+              <a:rPr lang="en-US" sz="900" dirty="0">
+                <a:solidFill>
+                  <a:srgbClr val="998C77"/>
+                </a:solidFill>
+                <a:latin typeface="Calibri" pitchFamily="34" charset="0"/>
+                <a:ea typeface="Calibri" pitchFamily="34" charset="-122"/>
+                <a:cs typeface="Calibri" pitchFamily="34" charset="-120"/>
+              </a:rPr>
+              <a:t>3</a:t>
+            </a:r>
+            <a:endParaRPr lang="en-US" sz="900" dirty="0"/>
+          </a:p>
+        </p:txBody>
+      </p:sp>
+    </p:spTree>
+  </p:cSld>
+  <p:clrMapOvr>
+    <a:masterClrMapping/>
+  </p:clrMapOvr>
+</p:sld>
+</file>
+
+<file path=ppt/slides/slide4.xml><?xml version="1.0" encoding="utf-8"?>
+<p:sld xmlns:a="http://schemas.openxmlformats.org/drawingml/2006/main" xmlns:r="http://schemas.openxmlformats.org/officeDocument/2006/relationships" xmlns:p="http://schemas.openxmlformats.org/presentationml/2006/main">
+  <p:cSld name="Slide 4">
+    <p:bg>
+      <p:bgPr>
+        <a:solidFill>
           <a:srgbClr val="FFFFFF"/>
         </a:solidFill>
       </p:bgPr>
@@ -2132,7 +3153,7 @@
                 <a:ea typeface="Calibri" pitchFamily="34" charset="-122"/>
                 <a:cs typeface="Calibri" pitchFamily="34" charset="-120"/>
               </a:rPr>
-              <a:t>2</a:t>
+              <a:t>4</a:t>
             </a:r>
             <a:endParaRPr lang="en-US" sz="900" dirty="0"/>
           </a:p>
@@ -2146,9 +3167,9 @@
 </p:sld>
 </file>
 
-<file path=ppt/slides/slide3.xml><?xml version="1.0" encoding="utf-8"?>
+<file path=ppt/slides/slide5.xml><?xml version="1.0" encoding="utf-8"?>
 <p:sld xmlns:a="http://schemas.openxmlformats.org/drawingml/2006/main" xmlns:r="http://schemas.openxmlformats.org/officeDocument/2006/relationships" xmlns:p="http://schemas.openxmlformats.org/presentationml/2006/main">
-  <p:cSld name="Slide 3">
+  <p:cSld name="Slide 5">
     <p:bg>
       <p:bgPr>
         <a:solidFill>
@@ -2936,7 +3957,7 @@
                 <a:ea typeface="Calibri" pitchFamily="34" charset="-122"/>
                 <a:cs typeface="Calibri" pitchFamily="34" charset="-120"/>
               </a:rPr>
-              <a:t>3</a:t>
+              <a:t>5</a:t>
             </a:r>
             <a:endParaRPr lang="en-US" sz="900" dirty="0"/>
           </a:p>
@@ -2950,9 +3971,9 @@
 </p:sld>
 </file>
 
-<file path=ppt/slides/slide4.xml><?xml version="1.0" encoding="utf-8"?>
+<file path=ppt/slides/slide6.xml><?xml version="1.0" encoding="utf-8"?>
 <p:sld xmlns:a="http://schemas.openxmlformats.org/drawingml/2006/main" xmlns:r="http://schemas.openxmlformats.org/officeDocument/2006/relationships" xmlns:p="http://schemas.openxmlformats.org/presentationml/2006/main">
-  <p:cSld name="Slide 4">
+  <p:cSld name="Slide 6">
     <p:bg>
       <p:bgPr>
         <a:solidFill>
@@ -3136,7 +4157,7 @@
       </p:sp>
       <p:graphicFrame>
         <p:nvGraphicFramePr>
-          <p:cNvPr id="5" name="Table 0"/>
+          <p:cNvPr id="7" name="Table 0"/>
           <p:cNvGraphicFramePr>
             <a:graphicFrameLocks noGrp="1"/>
           </p:cNvGraphicFramePr>
@@ -6298,9 +7319,9 @@
 </p:sld>
 </file>
 
-<file path=ppt/slides/slide5.xml><?xml version="1.0" encoding="utf-8"?>
+<file path=ppt/slides/slide7.xml><?xml version="1.0" encoding="utf-8"?>
 <p:sld xmlns:a="http://schemas.openxmlformats.org/drawingml/2006/main" xmlns:r="http://schemas.openxmlformats.org/officeDocument/2006/relationships" xmlns:p="http://schemas.openxmlformats.org/presentationml/2006/main">
-  <p:cSld name="Slide 5">
+  <p:cSld name="Slide 7">
     <p:bg>
       <p:bgPr>
         <a:solidFill>
@@ -6445,7 +7466,7 @@
       </p:sp>
       <p:graphicFrame>
         <p:nvGraphicFramePr>
-          <p:cNvPr id="6" name="Table 0"/>
+          <p:cNvPr id="8" name="Table 0"/>
           <p:cNvGraphicFramePr>
             <a:graphicFrameLocks noGrp="1"/>
           </p:cNvGraphicFramePr>
@@ -9871,9 +10892,9 @@
 </p:sld>
 </file>
 
-<file path=ppt/slides/slide6.xml><?xml version="1.0" encoding="utf-8"?>
+<file path=ppt/slides/slide8.xml><?xml version="1.0" encoding="utf-8"?>
 <p:sld xmlns:a="http://schemas.openxmlformats.org/drawingml/2006/main" xmlns:r="http://schemas.openxmlformats.org/officeDocument/2006/relationships" xmlns:p="http://schemas.openxmlformats.org/presentationml/2006/main">
-  <p:cSld name="Slide 6">
+  <p:cSld name="Slide 8">
     <p:bg>
       <p:bgPr>
         <a:solidFill>
@@ -10474,7 +11495,7 @@
                 <a:ea typeface="Calibri" pitchFamily="34" charset="-122"/>
                 <a:cs typeface="Calibri" pitchFamily="34" charset="-120"/>
               </a:rPr>
-              <a:t>6</a:t>
+              <a:t>8</a:t>
             </a:r>
             <a:endParaRPr lang="en-US" sz="900" dirty="0"/>
           </a:p>
@@ -10488,9 +11509,9 @@
 </p:sld>
 </file>
 
-<file path=ppt/slides/slide7.xml><?xml version="1.0" encoding="utf-8"?>
+<file path=ppt/slides/slide9.xml><?xml version="1.0" encoding="utf-8"?>
 <p:sld xmlns:a="http://schemas.openxmlformats.org/drawingml/2006/main" xmlns:r="http://schemas.openxmlformats.org/officeDocument/2006/relationships" xmlns:p="http://schemas.openxmlformats.org/presentationml/2006/main">
-  <p:cSld name="Slide 7">
+  <p:cSld name="Slide 9">
     <p:bg>
       <p:bgPr>
         <a:solidFill>
@@ -11234,7 +12255,7 @@
                 <a:ea typeface="Calibri" pitchFamily="34" charset="-122"/>
                 <a:cs typeface="Calibri" pitchFamily="34" charset="-120"/>
               </a:rPr>
-              <a:t>7</a:t>
+              <a:t>9</a:t>
             </a:r>
             <a:endParaRPr lang="en-US" sz="900" dirty="0"/>
           </a:p>

</xml_diff>

<commit_message>
Geschichte 11: Urteile im Hefter statt Urteilsblatt, Maßstäbe auf der Folie
Co-Authored-By: Claude Opus 5.5 <noreply@anthropic.com>
Claude-Session: https://claude.ai/code/session_013iN4Tiarea1J9YUJHZ9iqC
</commit_message>
<xml_diff>
--- a/Geschichte_11/Stunde_Buergeramt_Athen/Folien_Buergeramt_Athen.pptx
+++ b/Geschichte_11/Stunde_Buergeramt_Athen/Folien_Buergeramt_Athen.pptx
@@ -870,7 +870,7 @@
           <a:p>
             <a:r>
               <a:rPr lang="en-US" dirty="0"/>
-              <a:t>46–52 Min. Urteilsblatt austeilen, Einzelarbeit. Danach vergleicht jeder still mit dem Beispiel auf der nächsten Folie.</a:t>
+              <a:t>46–52 Min. Einzelarbeit im Hefter. Danach vergleicht jeder still mit dem Beispiel auf der nächsten Folie.</a:t>
             </a:r>
             <a:endParaRPr lang="en-US" dirty="0"/>
           </a:p>
@@ -1046,7 +1046,7 @@
           <a:p>
             <a:r>
               <a:rPr lang="en-US" dirty="0"/>
-              <a:t>53–60 Min. Alle beantworten dieselbe Frage, jeder wählt seinen Maßstab selbst. Das Urteilsblatt wird am Ende eingesammelt – so siehst du, wie sicher die Klasse Sach- und Werturteil inzwischen beherrscht.</a:t>
+              <a:t>53–60 Min. Alle beantworten dieselbe Frage, jeder wählt seinen Maßstab selbst. Bei Bedarf Hefter einsammeln – so siehst du, wie sicher die Klasse Sach- und Werturteil inzwischen beherrscht.</a:t>
             </a:r>
             <a:endParaRPr lang="en-US" dirty="0"/>
           </a:p>
@@ -1222,7 +1222,7 @@
           <a:p>
             <a:r>
               <a:rPr lang="en-US" dirty="0"/>
-              <a:t>65–70 Min. Optional vorher zwei Schülerurteile vorlesen (gelungen / zu verbessern) und kurz an der Checkliste messen. Danach Urteilsblätter einsammeln. Anschließend: Klausurvorbereitung.</a:t>
+              <a:t>65–70 Min. Optional vorher zwei Schülerurteile vorlesen (gelungen / zu verbessern) und kurz an der Checkliste messen. Bei Bedarf Hefter einsammeln. Anschließend: Klausurvorbereitung.</a:t>
             </a:r>
             <a:endParaRPr lang="en-US" dirty="0"/>
           </a:p>
@@ -4367,7 +4367,7 @@
                 <a:ea typeface="Calibri" pitchFamily="34" charset="-122"/>
                 <a:cs typeface="Calibri" pitchFamily="34" charset="-120"/>
               </a:rPr>
-              <a:t>EINZELARBEIT · URTEILSBLATT</a:t>
+              <a:t>EINZELARBEIT · HEFTER</a:t>
             </a:r>
             <a:endParaRPr lang="en-US" sz="1100" dirty="0"/>
           </a:p>
@@ -5667,7 +5667,7 @@
                 <a:ea typeface="Calibri" pitchFamily="34" charset="-122"/>
                 <a:cs typeface="Calibri" pitchFamily="34" charset="-120"/>
               </a:rPr>
-              <a:t>EINZELARBEIT · URTEILSBLATT</a:t>
+              <a:t>EINZELARBEIT · HEFTER</a:t>
             </a:r>
             <a:endParaRPr lang="en-US" sz="1100" dirty="0"/>
           </a:p>
@@ -5823,18 +5823,57 @@
       </p:sp>
       <p:sp>
         <p:nvSpPr>
-          <p:cNvPr id="7" name="Shape 5"/>
+          <p:cNvPr id="7" name="Text 5"/>
+          <p:cNvSpPr txBox="1"/>
+          <p:nvPr/>
+        </p:nvSpPr>
+        <p:spPr>
+          <a:xfrm>
+            <a:off x="457200" y="2057400"/>
+            <a:ext cx="2743200" cy="228600"/>
+          </a:xfrm>
+          <a:prstGeom prst="rect">
+            <a:avLst/>
+          </a:prstGeom>
+          <a:noFill/>
+          <a:ln/>
+        </p:spPr>
+        <p:txBody>
+          <a:bodyPr wrap="square" lIns="0" tIns="0" rIns="0" bIns="0" rtlCol="0" anchor="t"/>
+          <a:lstStyle/>
+          <a:p>
+            <a:pPr indent="0" marL="0">
+              <a:buNone/>
+            </a:pPr>
+            <a:r>
+              <a:rPr lang="en-US" sz="1000" b="1" spc="200" kern="0" dirty="0">
+                <a:solidFill>
+                  <a:srgbClr val="5A5044"/>
+                </a:solidFill>
+                <a:latin typeface="Calibri" pitchFamily="34" charset="0"/>
+                <a:ea typeface="Calibri" pitchFamily="34" charset="-122"/>
+                <a:cs typeface="Calibri" pitchFamily="34" charset="-120"/>
+              </a:rPr>
+              <a:t>MASSSTÄBE</a:t>
+            </a:r>
+            <a:endParaRPr lang="en-US" sz="1000" dirty="0"/>
+          </a:p>
+        </p:txBody>
+      </p:sp>
+      <p:sp>
+        <p:nvSpPr>
+          <p:cNvPr id="8" name="Shape 6"/>
           <p:cNvSpPr/>
           <p:nvPr/>
         </p:nvSpPr>
         <p:spPr>
           <a:xfrm>
-            <a:off x="457200" y="2148840"/>
-            <a:ext cx="1947672" cy="502920"/>
+            <a:off x="457200" y="2304288"/>
+            <a:ext cx="1947672" cy="914400"/>
           </a:xfrm>
           <a:prstGeom prst="roundRect">
             <a:avLst>
-              <a:gd name="adj" fmla="val 14545"/>
+              <a:gd name="adj" fmla="val 8000"/>
             </a:avLst>
           </a:prstGeom>
           <a:solidFill>
@@ -5850,13 +5889,13 @@
       </p:sp>
       <p:sp>
         <p:nvSpPr>
-          <p:cNvPr id="8" name="Text 6"/>
-          <p:cNvSpPr txBox="1"/>
-          <p:nvPr/>
-        </p:nvSpPr>
-        <p:spPr>
-          <a:xfrm>
-            <a:off x="548640" y="2212848"/>
+          <p:cNvPr id="9" name="Text 7"/>
+          <p:cNvSpPr txBox="1"/>
+          <p:nvPr/>
+        </p:nvSpPr>
+        <p:spPr>
+          <a:xfrm>
+            <a:off x="548640" y="2377440"/>
             <a:ext cx="365760" cy="365760"/>
           </a:xfrm>
           <a:prstGeom prst="ellipse">
@@ -5891,14 +5930,14 @@
       </p:sp>
       <p:sp>
         <p:nvSpPr>
-          <p:cNvPr id="9" name="Text 7"/>
-          <p:cNvSpPr txBox="1"/>
-          <p:nvPr/>
-        </p:nvSpPr>
-        <p:spPr>
-          <a:xfrm>
-            <a:off x="1005840" y="2148840"/>
-            <a:ext cx="1371600" cy="502920"/>
+          <p:cNvPr id="10" name="Text 8"/>
+          <p:cNvSpPr txBox="1"/>
+          <p:nvPr/>
+        </p:nvSpPr>
+        <p:spPr>
+          <a:xfrm>
+            <a:off x="987552" y="2377440"/>
+            <a:ext cx="1371600" cy="365760"/>
           </a:xfrm>
           <a:prstGeom prst="rect">
             <a:avLst/>
@@ -5914,7 +5953,7 @@
               <a:buNone/>
             </a:pPr>
             <a:r>
-              <a:rPr lang="en-US" sz="1200" b="1" dirty="0">
+              <a:rPr lang="en-US" sz="1250" b="1" dirty="0">
                 <a:solidFill>
                   <a:srgbClr val="2B2318"/>
                 </a:solidFill>
@@ -5924,24 +5963,63 @@
               </a:rPr>
               <a:t>Gleichheit</a:t>
             </a:r>
-            <a:endParaRPr lang="en-US" sz="1200" dirty="0"/>
-          </a:p>
-        </p:txBody>
-      </p:sp>
-      <p:sp>
-        <p:nvSpPr>
-          <p:cNvPr id="10" name="Shape 8"/>
+            <a:endParaRPr lang="en-US" sz="1250" dirty="0"/>
+          </a:p>
+        </p:txBody>
+      </p:sp>
+      <p:sp>
+        <p:nvSpPr>
+          <p:cNvPr id="11" name="Text 9"/>
+          <p:cNvSpPr txBox="1"/>
+          <p:nvPr/>
+        </p:nvSpPr>
+        <p:spPr>
+          <a:xfrm>
+            <a:off x="566928" y="2779776"/>
+            <a:ext cx="1783080" cy="411480"/>
+          </a:xfrm>
+          <a:prstGeom prst="rect">
+            <a:avLst/>
+          </a:prstGeom>
+          <a:noFill/>
+          <a:ln/>
+        </p:spPr>
+        <p:txBody>
+          <a:bodyPr wrap="square" lIns="0" tIns="0" rIns="0" bIns="0" rtlCol="0" anchor="t"/>
+          <a:lstStyle/>
+          <a:p>
+            <a:pPr indent="0" marL="0">
+              <a:buNone/>
+            </a:pPr>
+            <a:r>
+              <a:rPr lang="en-US" sz="1000" dirty="0">
+                <a:solidFill>
+                  <a:srgbClr val="5A5044"/>
+                </a:solidFill>
+                <a:latin typeface="Calibri" pitchFamily="34" charset="0"/>
+                <a:ea typeface="Calibri" pitchFamily="34" charset="-122"/>
+                <a:cs typeface="Calibri" pitchFamily="34" charset="-120"/>
+              </a:rPr>
+              <a:t>Alle bekommen das Gleiche.</a:t>
+            </a:r>
+            <a:endParaRPr lang="en-US" sz="1000" dirty="0"/>
+          </a:p>
+        </p:txBody>
+      </p:sp>
+      <p:sp>
+        <p:nvSpPr>
+          <p:cNvPr id="12" name="Shape 10"/>
           <p:cNvSpPr/>
           <p:nvPr/>
         </p:nvSpPr>
         <p:spPr>
           <a:xfrm>
-            <a:off x="2551176" y="2148840"/>
-            <a:ext cx="1947672" cy="502920"/>
+            <a:off x="2551176" y="2304288"/>
+            <a:ext cx="1947672" cy="914400"/>
           </a:xfrm>
           <a:prstGeom prst="roundRect">
             <a:avLst>
-              <a:gd name="adj" fmla="val 14545"/>
+              <a:gd name="adj" fmla="val 8000"/>
             </a:avLst>
           </a:prstGeom>
           <a:solidFill>
@@ -5957,13 +6035,13 @@
       </p:sp>
       <p:sp>
         <p:nvSpPr>
-          <p:cNvPr id="11" name="Text 9"/>
-          <p:cNvSpPr txBox="1"/>
-          <p:nvPr/>
-        </p:nvSpPr>
-        <p:spPr>
-          <a:xfrm>
-            <a:off x="2642616" y="2212848"/>
+          <p:cNvPr id="13" name="Text 11"/>
+          <p:cNvSpPr txBox="1"/>
+          <p:nvPr/>
+        </p:nvSpPr>
+        <p:spPr>
+          <a:xfrm>
+            <a:off x="2642616" y="2377440"/>
             <a:ext cx="365760" cy="365760"/>
           </a:xfrm>
           <a:prstGeom prst="ellipse">
@@ -5998,14 +6076,14 @@
       </p:sp>
       <p:sp>
         <p:nvSpPr>
-          <p:cNvPr id="12" name="Text 10"/>
-          <p:cNvSpPr txBox="1"/>
-          <p:nvPr/>
-        </p:nvSpPr>
-        <p:spPr>
-          <a:xfrm>
-            <a:off x="3099816" y="2148840"/>
-            <a:ext cx="1371600" cy="502920"/>
+          <p:cNvPr id="14" name="Text 12"/>
+          <p:cNvSpPr txBox="1"/>
+          <p:nvPr/>
+        </p:nvSpPr>
+        <p:spPr>
+          <a:xfrm>
+            <a:off x="3081528" y="2377440"/>
+            <a:ext cx="1371600" cy="365760"/>
           </a:xfrm>
           <a:prstGeom prst="rect">
             <a:avLst/>
@@ -6021,7 +6099,7 @@
               <a:buNone/>
             </a:pPr>
             <a:r>
-              <a:rPr lang="en-US" sz="1200" b="1" dirty="0">
+              <a:rPr lang="en-US" sz="1250" b="1" dirty="0">
                 <a:solidFill>
                   <a:srgbClr val="2B2318"/>
                 </a:solidFill>
@@ -6031,24 +6109,63 @@
               </a:rPr>
               <a:t>Leistung</a:t>
             </a:r>
-            <a:endParaRPr lang="en-US" sz="1200" dirty="0"/>
-          </a:p>
-        </p:txBody>
-      </p:sp>
-      <p:sp>
-        <p:nvSpPr>
-          <p:cNvPr id="13" name="Shape 11"/>
+            <a:endParaRPr lang="en-US" sz="1250" dirty="0"/>
+          </a:p>
+        </p:txBody>
+      </p:sp>
+      <p:sp>
+        <p:nvSpPr>
+          <p:cNvPr id="15" name="Text 13"/>
+          <p:cNvSpPr txBox="1"/>
+          <p:nvPr/>
+        </p:nvSpPr>
+        <p:spPr>
+          <a:xfrm>
+            <a:off x="2660904" y="2779776"/>
+            <a:ext cx="1783080" cy="411480"/>
+          </a:xfrm>
+          <a:prstGeom prst="rect">
+            <a:avLst/>
+          </a:prstGeom>
+          <a:noFill/>
+          <a:ln/>
+        </p:spPr>
+        <p:txBody>
+          <a:bodyPr wrap="square" lIns="0" tIns="0" rIns="0" bIns="0" rtlCol="0" anchor="t"/>
+          <a:lstStyle/>
+          <a:p>
+            <a:pPr indent="0" marL="0">
+              <a:buNone/>
+            </a:pPr>
+            <a:r>
+              <a:rPr lang="en-US" sz="1000" dirty="0">
+                <a:solidFill>
+                  <a:srgbClr val="5A5044"/>
+                </a:solidFill>
+                <a:latin typeface="Calibri" pitchFamily="34" charset="0"/>
+                <a:ea typeface="Calibri" pitchFamily="34" charset="-122"/>
+                <a:cs typeface="Calibri" pitchFamily="34" charset="-120"/>
+              </a:rPr>
+              <a:t>Wer mehr leistet oder trägt, bekommt mehr.</a:t>
+            </a:r>
+            <a:endParaRPr lang="en-US" sz="1000" dirty="0"/>
+          </a:p>
+        </p:txBody>
+      </p:sp>
+      <p:sp>
+        <p:nvSpPr>
+          <p:cNvPr id="16" name="Shape 14"/>
           <p:cNvSpPr/>
           <p:nvPr/>
         </p:nvSpPr>
         <p:spPr>
           <a:xfrm>
-            <a:off x="4645152" y="2148840"/>
-            <a:ext cx="1947672" cy="502920"/>
+            <a:off x="4645152" y="2304288"/>
+            <a:ext cx="1947672" cy="914400"/>
           </a:xfrm>
           <a:prstGeom prst="roundRect">
             <a:avLst>
-              <a:gd name="adj" fmla="val 14545"/>
+              <a:gd name="adj" fmla="val 8000"/>
             </a:avLst>
           </a:prstGeom>
           <a:solidFill>
@@ -6064,13 +6181,13 @@
       </p:sp>
       <p:sp>
         <p:nvSpPr>
-          <p:cNvPr id="14" name="Text 12"/>
-          <p:cNvSpPr txBox="1"/>
-          <p:nvPr/>
-        </p:nvSpPr>
-        <p:spPr>
-          <a:xfrm>
-            <a:off x="4736592" y="2212848"/>
+          <p:cNvPr id="17" name="Text 15"/>
+          <p:cNvSpPr txBox="1"/>
+          <p:nvPr/>
+        </p:nvSpPr>
+        <p:spPr>
+          <a:xfrm>
+            <a:off x="4736592" y="2377440"/>
             <a:ext cx="365760" cy="365760"/>
           </a:xfrm>
           <a:prstGeom prst="ellipse">
@@ -6105,14 +6222,14 @@
       </p:sp>
       <p:sp>
         <p:nvSpPr>
-          <p:cNvPr id="15" name="Text 13"/>
-          <p:cNvSpPr txBox="1"/>
-          <p:nvPr/>
-        </p:nvSpPr>
-        <p:spPr>
-          <a:xfrm>
-            <a:off x="5193792" y="2148840"/>
-            <a:ext cx="1371600" cy="502920"/>
+          <p:cNvPr id="18" name="Text 16"/>
+          <p:cNvSpPr txBox="1"/>
+          <p:nvPr/>
+        </p:nvSpPr>
+        <p:spPr>
+          <a:xfrm>
+            <a:off x="5175504" y="2377440"/>
+            <a:ext cx="1371600" cy="365760"/>
           </a:xfrm>
           <a:prstGeom prst="rect">
             <a:avLst/>
@@ -6128,7 +6245,7 @@
               <a:buNone/>
             </a:pPr>
             <a:r>
-              <a:rPr lang="en-US" sz="1200" b="1" dirty="0">
+              <a:rPr lang="en-US" sz="1100" b="1" dirty="0">
                 <a:solidFill>
                   <a:srgbClr val="2B2318"/>
                 </a:solidFill>
@@ -6138,24 +6255,63 @@
               </a:rPr>
               <a:t>Schutz der Schwachen</a:t>
             </a:r>
-            <a:endParaRPr lang="en-US" sz="1200" dirty="0"/>
-          </a:p>
-        </p:txBody>
-      </p:sp>
-      <p:sp>
-        <p:nvSpPr>
-          <p:cNvPr id="16" name="Shape 14"/>
+            <a:endParaRPr lang="en-US" sz="1100" dirty="0"/>
+          </a:p>
+        </p:txBody>
+      </p:sp>
+      <p:sp>
+        <p:nvSpPr>
+          <p:cNvPr id="19" name="Text 17"/>
+          <p:cNvSpPr txBox="1"/>
+          <p:nvPr/>
+        </p:nvSpPr>
+        <p:spPr>
+          <a:xfrm>
+            <a:off x="4754880" y="2779776"/>
+            <a:ext cx="1783080" cy="411480"/>
+          </a:xfrm>
+          <a:prstGeom prst="rect">
+            <a:avLst/>
+          </a:prstGeom>
+          <a:noFill/>
+          <a:ln/>
+        </p:spPr>
+        <p:txBody>
+          <a:bodyPr wrap="square" lIns="0" tIns="0" rIns="0" bIns="0" rtlCol="0" anchor="t"/>
+          <a:lstStyle/>
+          <a:p>
+            <a:pPr indent="0" marL="0">
+              <a:buNone/>
+            </a:pPr>
+            <a:r>
+              <a:rPr lang="en-US" sz="1000" dirty="0">
+                <a:solidFill>
+                  <a:srgbClr val="5A5044"/>
+                </a:solidFill>
+                <a:latin typeface="Calibri" pitchFamily="34" charset="0"/>
+                <a:ea typeface="Calibri" pitchFamily="34" charset="-122"/>
+                <a:cs typeface="Calibri" pitchFamily="34" charset="-120"/>
+              </a:rPr>
+              <a:t>Die Schwachen werden geschützt.</a:t>
+            </a:r>
+            <a:endParaRPr lang="en-US" sz="1000" dirty="0"/>
+          </a:p>
+        </p:txBody>
+      </p:sp>
+      <p:sp>
+        <p:nvSpPr>
+          <p:cNvPr id="20" name="Shape 18"/>
           <p:cNvSpPr/>
           <p:nvPr/>
         </p:nvSpPr>
         <p:spPr>
           <a:xfrm>
-            <a:off x="6739128" y="2148840"/>
-            <a:ext cx="1947672" cy="502920"/>
+            <a:off x="6739128" y="2304288"/>
+            <a:ext cx="1947672" cy="914400"/>
           </a:xfrm>
           <a:prstGeom prst="roundRect">
             <a:avLst>
-              <a:gd name="adj" fmla="val 14545"/>
+              <a:gd name="adj" fmla="val 8000"/>
             </a:avLst>
           </a:prstGeom>
           <a:solidFill>
@@ -6171,13 +6327,13 @@
       </p:sp>
       <p:sp>
         <p:nvSpPr>
-          <p:cNvPr id="17" name="Text 15"/>
-          <p:cNvSpPr txBox="1"/>
-          <p:nvPr/>
-        </p:nvSpPr>
-        <p:spPr>
-          <a:xfrm>
-            <a:off x="6830568" y="2212848"/>
+          <p:cNvPr id="21" name="Text 19"/>
+          <p:cNvSpPr txBox="1"/>
+          <p:nvPr/>
+        </p:nvSpPr>
+        <p:spPr>
+          <a:xfrm>
+            <a:off x="6830568" y="2377440"/>
             <a:ext cx="365760" cy="365760"/>
           </a:xfrm>
           <a:prstGeom prst="ellipse">
@@ -6212,14 +6368,14 @@
       </p:sp>
       <p:sp>
         <p:nvSpPr>
-          <p:cNvPr id="18" name="Text 16"/>
-          <p:cNvSpPr txBox="1"/>
-          <p:nvPr/>
-        </p:nvSpPr>
-        <p:spPr>
-          <a:xfrm>
-            <a:off x="7287768" y="2148840"/>
-            <a:ext cx="1371600" cy="502920"/>
+          <p:cNvPr id="22" name="Text 20"/>
+          <p:cNvSpPr txBox="1"/>
+          <p:nvPr/>
+        </p:nvSpPr>
+        <p:spPr>
+          <a:xfrm>
+            <a:off x="7269480" y="2377440"/>
+            <a:ext cx="1371600" cy="365760"/>
           </a:xfrm>
           <a:prstGeom prst="rect">
             <a:avLst/>
@@ -6235,7 +6391,7 @@
               <a:buNone/>
             </a:pPr>
             <a:r>
-              <a:rPr lang="en-US" sz="1200" b="1" dirty="0">
+              <a:rPr lang="en-US" sz="1250" b="1" dirty="0">
                 <a:solidFill>
                   <a:srgbClr val="2B2318"/>
                 </a:solidFill>
@@ -6245,19 +6401,58 @@
               </a:rPr>
               <a:t>Gleiche Regeln</a:t>
             </a:r>
-            <a:endParaRPr lang="en-US" sz="1200" dirty="0"/>
-          </a:p>
-        </p:txBody>
-      </p:sp>
-      <p:sp>
-        <p:nvSpPr>
-          <p:cNvPr id="19" name="Text 17"/>
-          <p:cNvSpPr txBox="1"/>
-          <p:nvPr/>
-        </p:nvSpPr>
-        <p:spPr>
-          <a:xfrm>
-            <a:off x="457200" y="2880360"/>
+            <a:endParaRPr lang="en-US" sz="1250" dirty="0"/>
+          </a:p>
+        </p:txBody>
+      </p:sp>
+      <p:sp>
+        <p:nvSpPr>
+          <p:cNvPr id="23" name="Text 21"/>
+          <p:cNvSpPr txBox="1"/>
+          <p:nvPr/>
+        </p:nvSpPr>
+        <p:spPr>
+          <a:xfrm>
+            <a:off x="6848856" y="2779776"/>
+            <a:ext cx="1783080" cy="411480"/>
+          </a:xfrm>
+          <a:prstGeom prst="rect">
+            <a:avLst/>
+          </a:prstGeom>
+          <a:noFill/>
+          <a:ln/>
+        </p:spPr>
+        <p:txBody>
+          <a:bodyPr wrap="square" lIns="0" tIns="0" rIns="0" bIns="0" rtlCol="0" anchor="t"/>
+          <a:lstStyle/>
+          <a:p>
+            <a:pPr indent="0" marL="0">
+              <a:buNone/>
+            </a:pPr>
+            <a:r>
+              <a:rPr lang="en-US" sz="1000" dirty="0">
+                <a:solidFill>
+                  <a:srgbClr val="5A5044"/>
+                </a:solidFill>
+                <a:latin typeface="Calibri" pitchFamily="34" charset="0"/>
+                <a:ea typeface="Calibri" pitchFamily="34" charset="-122"/>
+                <a:cs typeface="Calibri" pitchFamily="34" charset="-120"/>
+              </a:rPr>
+              <a:t>Für alle gelten dieselben Regeln.</a:t>
+            </a:r>
+            <a:endParaRPr lang="en-US" sz="1000" dirty="0"/>
+          </a:p>
+        </p:txBody>
+      </p:sp>
+      <p:sp>
+        <p:nvSpPr>
+          <p:cNvPr id="24" name="Text 22"/>
+          <p:cNvSpPr txBox="1"/>
+          <p:nvPr/>
+        </p:nvSpPr>
+        <p:spPr>
+          <a:xfrm>
+            <a:off x="457200" y="3383280"/>
             <a:ext cx="365760" cy="365760"/>
           </a:xfrm>
           <a:prstGeom prst="ellipse">
@@ -6292,14 +6487,14 @@
       </p:sp>
       <p:sp>
         <p:nvSpPr>
-          <p:cNvPr id="20" name="Text 18"/>
-          <p:cNvSpPr txBox="1"/>
-          <p:nvPr/>
-        </p:nvSpPr>
-        <p:spPr>
-          <a:xfrm>
-            <a:off x="960120" y="2843784"/>
-            <a:ext cx="7726680" cy="493776"/>
+          <p:cNvPr id="25" name="Text 23"/>
+          <p:cNvSpPr txBox="1"/>
+          <p:nvPr/>
+        </p:nvSpPr>
+        <p:spPr>
+          <a:xfrm>
+            <a:off x="960120" y="3346704"/>
+            <a:ext cx="7726680" cy="402336"/>
           </a:xfrm>
           <a:prstGeom prst="rect">
             <a:avLst/>
@@ -6315,7 +6510,7 @@
               <a:buNone/>
             </a:pPr>
             <a:r>
-              <a:rPr lang="en-US" sz="1300" dirty="0">
+              <a:rPr lang="en-US" sz="1250" dirty="0">
                 <a:solidFill>
                   <a:srgbClr val="2B2318"/>
                 </a:solidFill>
@@ -6323,21 +6518,21 @@
                 <a:ea typeface="Calibri" pitchFamily="34" charset="-122"/>
                 <a:cs typeface="Calibri" pitchFamily="34" charset="-120"/>
               </a:rPr>
-              <a:t>Wähle einen Maßstab (1–4) und kreuze ihn auf dem Blatt an.</a:t>
-            </a:r>
-            <a:endParaRPr lang="en-US" sz="1300" dirty="0"/>
-          </a:p>
-        </p:txBody>
-      </p:sp>
-      <p:sp>
-        <p:nvSpPr>
-          <p:cNvPr id="21" name="Text 19"/>
-          <p:cNvSpPr txBox="1"/>
-          <p:nvPr/>
-        </p:nvSpPr>
-        <p:spPr>
-          <a:xfrm>
-            <a:off x="457200" y="3410712"/>
+              <a:t>Wähle einen Maßstab (1–4) und schreibe ihn über dein Urteil.</a:t>
+            </a:r>
+            <a:endParaRPr lang="en-US" sz="1250" dirty="0"/>
+          </a:p>
+        </p:txBody>
+      </p:sp>
+      <p:sp>
+        <p:nvSpPr>
+          <p:cNvPr id="26" name="Text 24"/>
+          <p:cNvSpPr txBox="1"/>
+          <p:nvPr/>
+        </p:nvSpPr>
+        <p:spPr>
+          <a:xfrm>
+            <a:off x="457200" y="3822192"/>
             <a:ext cx="365760" cy="365760"/>
           </a:xfrm>
           <a:prstGeom prst="ellipse">
@@ -6372,14 +6567,14 @@
       </p:sp>
       <p:sp>
         <p:nvSpPr>
-          <p:cNvPr id="22" name="Text 20"/>
-          <p:cNvSpPr txBox="1"/>
-          <p:nvPr/>
-        </p:nvSpPr>
-        <p:spPr>
-          <a:xfrm>
-            <a:off x="960120" y="3374136"/>
-            <a:ext cx="7726680" cy="493776"/>
+          <p:cNvPr id="27" name="Text 25"/>
+          <p:cNvSpPr txBox="1"/>
+          <p:nvPr/>
+        </p:nvSpPr>
+        <p:spPr>
+          <a:xfrm>
+            <a:off x="960120" y="3785616"/>
+            <a:ext cx="7726680" cy="402336"/>
           </a:xfrm>
           <a:prstGeom prst="rect">
             <a:avLst/>
@@ -6395,7 +6590,7 @@
               <a:buNone/>
             </a:pPr>
             <a:r>
-              <a:rPr lang="en-US" sz="1300" dirty="0">
+              <a:rPr lang="en-US" sz="1250" dirty="0">
                 <a:solidFill>
                   <a:srgbClr val="2B2318"/>
                 </a:solidFill>
@@ -6405,19 +6600,19 @@
               </a:rPr>
               <a:t>Schreibe 2–3 Sätze: „Gemessen an … halte ich es für gerecht / teilweise gerecht / nicht gerecht, weil …“</a:t>
             </a:r>
-            <a:endParaRPr lang="en-US" sz="1300" dirty="0"/>
-          </a:p>
-        </p:txBody>
-      </p:sp>
-      <p:sp>
-        <p:nvSpPr>
-          <p:cNvPr id="23" name="Text 21"/>
-          <p:cNvSpPr txBox="1"/>
-          <p:nvPr/>
-        </p:nvSpPr>
-        <p:spPr>
-          <a:xfrm>
-            <a:off x="457200" y="3941064"/>
+            <a:endParaRPr lang="en-US" sz="1250" dirty="0"/>
+          </a:p>
+        </p:txBody>
+      </p:sp>
+      <p:sp>
+        <p:nvSpPr>
+          <p:cNvPr id="28" name="Text 26"/>
+          <p:cNvSpPr txBox="1"/>
+          <p:nvPr/>
+        </p:nvSpPr>
+        <p:spPr>
+          <a:xfrm>
+            <a:off x="457200" y="4261104"/>
             <a:ext cx="365760" cy="365760"/>
           </a:xfrm>
           <a:prstGeom prst="ellipse">
@@ -6452,14 +6647,14 @@
       </p:sp>
       <p:sp>
         <p:nvSpPr>
-          <p:cNvPr id="24" name="Text 22"/>
-          <p:cNvSpPr txBox="1"/>
-          <p:nvPr/>
-        </p:nvSpPr>
-        <p:spPr>
-          <a:xfrm>
-            <a:off x="960120" y="3904488"/>
-            <a:ext cx="7726680" cy="493776"/>
+          <p:cNvPr id="29" name="Text 27"/>
+          <p:cNvSpPr txBox="1"/>
+          <p:nvPr/>
+        </p:nvSpPr>
+        <p:spPr>
+          <a:xfrm>
+            <a:off x="960120" y="4224528"/>
+            <a:ext cx="7726680" cy="402336"/>
           </a:xfrm>
           <a:prstGeom prst="rect">
             <a:avLst/>
@@ -6475,7 +6670,7 @@
               <a:buNone/>
             </a:pPr>
             <a:r>
-              <a:rPr lang="en-US" sz="1300" dirty="0">
+              <a:rPr lang="en-US" sz="1250" dirty="0">
                 <a:solidFill>
                   <a:srgbClr val="2B2318"/>
                 </a:solidFill>
@@ -6485,13 +6680,13 @@
               </a:rPr>
               <a:t>Begründe mit mindestens einem Beispiel aus dem Bürgeramt.</a:t>
             </a:r>
-            <a:endParaRPr lang="en-US" sz="1300" dirty="0"/>
-          </a:p>
-        </p:txBody>
-      </p:sp>
-      <p:sp>
-        <p:nvSpPr>
-          <p:cNvPr id="25" name="Text 23"/>
+            <a:endParaRPr lang="en-US" sz="1250" dirty="0"/>
+          </a:p>
+        </p:txBody>
+      </p:sp>
+      <p:sp>
+        <p:nvSpPr>
+          <p:cNvPr id="30" name="Text 28"/>
           <p:cNvSpPr txBox="1"/>
           <p:nvPr/>
         </p:nvSpPr>
@@ -6530,7 +6725,7 @@
       </p:sp>
       <p:sp>
         <p:nvSpPr>
-          <p:cNvPr id="26" name="Text 24"/>
+          <p:cNvPr id="31" name="Text 29"/>
           <p:cNvSpPr txBox="1"/>
           <p:nvPr/>
         </p:nvSpPr>
@@ -6632,7 +6827,7 @@
                 <a:ea typeface="Calibri" pitchFamily="34" charset="-122"/>
                 <a:cs typeface="Calibri" pitchFamily="34" charset="-120"/>
               </a:rPr>
-              <a:t>PARTNERARBEIT · URTEILSBLATT</a:t>
+              <a:t>PARTNERARBEIT · HEFTER</a:t>
             </a:r>
             <a:endParaRPr lang="en-US" sz="1100" dirty="0"/>
           </a:p>
@@ -6753,7 +6948,7 @@
                 <a:ea typeface="Calibri" pitchFamily="34" charset="-122"/>
                 <a:cs typeface="Calibri" pitchFamily="34" charset="-120"/>
               </a:rPr>
-              <a:t>Tauscht die Blätter. Prüft das Urteil eures Partners mit der Checkliste unten auf dem Blatt und schreibt einen Tipp dazu.</a:t>
+              <a:t>Tauscht die Hefter. Prüft die Urteile eures Partners mit der Checkliste und schreibt einen Tipp darunter.</a:t>
             </a:r>
             <a:endParaRPr lang="en-US" sz="1350" dirty="0"/>
           </a:p>

</xml_diff>

<commit_message>
Bürgeramt Athen: stummes Schaubild zeigt direkt, was jede Klasse darf
Ankreuzrechte pro Klasse (abstimmen, klagen, in den Rat, Archont werden),
Pfeile zu den Ämtern; Folien 8–9 und Handreichung angepasst.

Co-Authored-By: Claude Opus 5.5 <noreply@anthropic.com>
Claude-Session: https://claude.ai/code/session_013iN4Tiarea1J9YUJHZ9iqC
</commit_message>
<xml_diff>
--- a/Geschichte_11/Stunde_Buergeramt_Athen/Folien_Buergeramt_Athen.pptx
+++ b/Geschichte_11/Stunde_Buergeramt_Athen/Folien_Buergeramt_Athen.pptx
@@ -17468,7 +17468,7 @@
                 <a:ea typeface="Calibri" pitchFamily="34" charset="-122"/>
                 <a:cs typeface="Calibri" pitchFamily="34" charset="-120"/>
               </a:rPr>
-              <a:t>Buch und Hefter zu! Das Schaubild auf dem Blatt ist anders angeordnet als im Buch.</a:t>
+              <a:t>Buch und Hefter zu! Wer darf was? Zeige es im Schaubild.</a:t>
             </a:r>
             <a:endParaRPr lang="en-US" sz="1600" dirty="0"/>
           </a:p>
@@ -17548,7 +17548,7 @@
                 <a:ea typeface="Calibri" pitchFamily="34" charset="-122"/>
                 <a:cs typeface="Calibri" pitchFamily="34" charset="-120"/>
               </a:rPr>
-              <a:t>Trage die Klassen und Organe in die leeren Kästen ein und ergänze die Überschrift.</a:t>
+              <a:t>Beschrifte die vier Ämter oben, die Volksversammlung und die vier Klassen (mit Scheffelgrenze).</a:t>
             </a:r>
             <a:endParaRPr lang="en-US" sz="1400" dirty="0"/>
           </a:p>
@@ -17628,7 +17628,7 @@
                 <a:ea typeface="Calibri" pitchFamily="34" charset="-122"/>
                 <a:cs typeface="Calibri" pitchFamily="34" charset="-120"/>
               </a:rPr>
-              <a:t>Schreibe auf, was die Pfeile 1–5 bedeuten.</a:t>
+              <a:t>Kreuze bei jeder Klasse an, was sie darf. Was sie nicht darf, streichst du rot durch.</a:t>
             </a:r>
             <a:endParaRPr lang="en-US" sz="1400" dirty="0"/>
           </a:p>
@@ -17708,7 +17708,7 @@
                 <a:ea typeface="Calibri" pitchFamily="34" charset="-122"/>
                 <a:cs typeface="Calibri" pitchFamily="34" charset="-120"/>
               </a:rPr>
-              <a:t>Lykon ist Thete: Kreise grün ein, was er darf. Streiche rot durch, was er nicht darf.</a:t>
+              <a:t>Zeichne Pfeile von jeder Klasse zu den Ämtern, in die sie gewählt werden kann.</a:t>
             </a:r>
             <a:endParaRPr lang="en-US" sz="1400" dirty="0"/>
           </a:p>
@@ -18027,7 +18027,7 @@
       </p:sp>
       <p:pic>
         <p:nvPicPr>
-          <p:cNvPr id="5" name="Image 0" descr="/tmp/claude-0/-home-user-Schule/9be99485-7769-5631-81b2-1e426720ceab/scratchpad/stumm_loesung.png">    </p:cNvPr>
+          <p:cNvPr id="5" name="Image 0" descr="/tmp/claude-0/-home-user-Schule/9be99485-7769-5631-81b2-1e426720ceab/scratchpad/stumm2_loesung.png">    </p:cNvPr>
           <p:cNvPicPr>
             <a:picLocks noChangeAspect="1"/>
           </p:cNvPicPr>
@@ -18041,8 +18041,8 @@
         </p:blipFill>
         <p:spPr>
           <a:xfrm>
-            <a:off x="457200" y="1188720"/>
-            <a:ext cx="4114800" cy="3236976"/>
+            <a:off x="365760" y="1143000"/>
+            <a:ext cx="4937760" cy="3337560"/>
           </a:xfrm>
           <a:prstGeom prst="rect">
             <a:avLst/>
@@ -18057,12 +18057,12 @@
         </p:nvSpPr>
         <p:spPr>
           <a:xfrm>
-            <a:off x="4983480" y="1188720"/>
-            <a:ext cx="3703320" cy="3246120"/>
+            <a:off x="5486400" y="1188720"/>
+            <a:ext cx="3200400" cy="3291840"/>
           </a:xfrm>
           <a:prstGeom prst="roundRect">
             <a:avLst>
-              <a:gd name="adj" fmla="val 2254"/>
+              <a:gd name="adj" fmla="val 2286"/>
             </a:avLst>
           </a:prstGeom>
           <a:solidFill>
@@ -18084,8 +18084,8 @@
         </p:nvSpPr>
         <p:spPr>
           <a:xfrm>
-            <a:off x="5166360" y="1261872"/>
-            <a:ext cx="2743200" cy="320040"/>
+            <a:off x="5669280" y="1261872"/>
+            <a:ext cx="2834640" cy="320040"/>
           </a:xfrm>
           <a:prstGeom prst="rect">
             <a:avLst/>
@@ -18109,7 +18109,7 @@
                 <a:ea typeface="Cambria" pitchFamily="34" charset="-122"/>
                 <a:cs typeface="Cambria" pitchFamily="34" charset="-120"/>
               </a:rPr>
-              <a:t>Die Pfeile</a:t>
+              <a:t>Wer darf was?</a:t>
             </a:r>
             <a:endParaRPr lang="en-US" sz="1500" dirty="0"/>
           </a:p>
@@ -18123,49 +18123,8 @@
         </p:nvSpPr>
         <p:spPr>
           <a:xfrm>
-            <a:off x="5166360" y="1691640"/>
-            <a:ext cx="329184" cy="329184"/>
-          </a:xfrm>
-          <a:prstGeom prst="ellipse">
-            <a:avLst/>
-          </a:prstGeom>
-          <a:solidFill>
-            <a:srgbClr val="AD4426"/>
-          </a:solidFill>
-          <a:ln/>
-        </p:spPr>
-        <p:txBody>
-          <a:bodyPr wrap="square" lIns="0" tIns="0" rIns="0" bIns="0" rtlCol="0" anchor="ctr"/>
-          <a:lstStyle/>
-          <a:p>
-            <a:pPr algn="ctr" indent="0" marL="0">
-              <a:buNone/>
-            </a:pPr>
-            <a:r>
-              <a:rPr lang="en-US" sz="1200" b="1" dirty="0">
-                <a:solidFill>
-                  <a:srgbClr val="FFFFFF"/>
-                </a:solidFill>
-                <a:latin typeface="Cambria" pitchFamily="34" charset="0"/>
-                <a:ea typeface="Cambria" pitchFamily="34" charset="-122"/>
-                <a:cs typeface="Cambria" pitchFamily="34" charset="-120"/>
-              </a:rPr>
-              <a:t>1</a:t>
-            </a:r>
-            <a:endParaRPr lang="en-US" sz="1200" dirty="0"/>
-          </a:p>
-        </p:txBody>
-      </p:sp>
-      <p:sp>
-        <p:nvSpPr>
-          <p:cNvPr id="9" name="Text 6"/>
-          <p:cNvSpPr txBox="1"/>
-          <p:nvPr/>
-        </p:nvSpPr>
-        <p:spPr>
-          <a:xfrm>
-            <a:off x="5577840" y="1664208"/>
-            <a:ext cx="3017520" cy="457200"/>
+            <a:off x="5669280" y="1645920"/>
+            <a:ext cx="2926080" cy="256032"/>
           </a:xfrm>
           <a:prstGeom prst="rect">
             <a:avLst/>
@@ -18174,14 +18133,14 @@
           <a:ln/>
         </p:spPr>
         <p:txBody>
-          <a:bodyPr wrap="square" lIns="0" tIns="0" rIns="0" bIns="0" rtlCol="0" anchor="ctr"/>
+          <a:bodyPr wrap="square" lIns="0" tIns="0" rIns="0" bIns="0" rtlCol="0" anchor="t"/>
           <a:lstStyle/>
           <a:p>
             <a:pPr indent="0" marL="0">
               <a:buNone/>
             </a:pPr>
             <a:r>
-              <a:rPr lang="en-US" sz="1150" dirty="0">
+              <a:rPr lang="en-US" sz="1200" b="1" dirty="0">
                 <a:solidFill>
                   <a:srgbClr val="2B2318"/>
                 </a:solidFill>
@@ -18189,48 +18148,7 @@
                 <a:ea typeface="Calibri" pitchFamily="34" charset="-122"/>
                 <a:cs typeface="Calibri" pitchFamily="34" charset="-120"/>
               </a:rPr>
-              <a:t>nur die 1. Klasse kann Archont werden</a:t>
-            </a:r>
-            <a:endParaRPr lang="en-US" sz="1150" dirty="0"/>
-          </a:p>
-        </p:txBody>
-      </p:sp>
-      <p:sp>
-        <p:nvSpPr>
-          <p:cNvPr id="10" name="Text 7"/>
-          <p:cNvSpPr txBox="1"/>
-          <p:nvPr/>
-        </p:nvSpPr>
-        <p:spPr>
-          <a:xfrm>
-            <a:off x="5166360" y="2221992"/>
-            <a:ext cx="329184" cy="329184"/>
-          </a:xfrm>
-          <a:prstGeom prst="ellipse">
-            <a:avLst/>
-          </a:prstGeom>
-          <a:solidFill>
-            <a:srgbClr val="AD4426"/>
-          </a:solidFill>
-          <a:ln/>
-        </p:spPr>
-        <p:txBody>
-          <a:bodyPr wrap="square" lIns="0" tIns="0" rIns="0" bIns="0" rtlCol="0" anchor="ctr"/>
-          <a:lstStyle/>
-          <a:p>
-            <a:pPr algn="ctr" indent="0" marL="0">
-              <a:buNone/>
-            </a:pPr>
-            <a:r>
-              <a:rPr lang="en-US" sz="1200" b="1" dirty="0">
-                <a:solidFill>
-                  <a:srgbClr val="FFFFFF"/>
-                </a:solidFill>
-                <a:latin typeface="Cambria" pitchFamily="34" charset="0"/>
-                <a:ea typeface="Cambria" pitchFamily="34" charset="-122"/>
-                <a:cs typeface="Cambria" pitchFamily="34" charset="-120"/>
-              </a:rPr>
-              <a:t>2</a:t>
+              <a:t>1. Klasse</a:t>
             </a:r>
             <a:endParaRPr lang="en-US" sz="1200" dirty="0"/>
           </a:p>
@@ -18238,14 +18156,14 @@
       </p:sp>
       <p:sp>
         <p:nvSpPr>
-          <p:cNvPr id="11" name="Text 8"/>
-          <p:cNvSpPr txBox="1"/>
-          <p:nvPr/>
-        </p:nvSpPr>
-        <p:spPr>
-          <a:xfrm>
-            <a:off x="5577840" y="2194560"/>
-            <a:ext cx="3017520" cy="457200"/>
+          <p:cNvPr id="9" name="Text 6"/>
+          <p:cNvSpPr txBox="1"/>
+          <p:nvPr/>
+        </p:nvSpPr>
+        <p:spPr>
+          <a:xfrm>
+            <a:off x="5669280" y="1883664"/>
+            <a:ext cx="2926080" cy="274320"/>
           </a:xfrm>
           <a:prstGeom prst="rect">
             <a:avLst/>
@@ -18254,63 +18172,22 @@
           <a:ln/>
         </p:spPr>
         <p:txBody>
-          <a:bodyPr wrap="square" lIns="0" tIns="0" rIns="0" bIns="0" rtlCol="0" anchor="ctr"/>
+          <a:bodyPr wrap="square" lIns="0" tIns="0" rIns="0" bIns="0" rtlCol="0" anchor="t"/>
           <a:lstStyle/>
           <a:p>
             <a:pPr indent="0" marL="0">
               <a:buNone/>
             </a:pPr>
             <a:r>
-              <a:rPr lang="en-US" sz="1150" dirty="0">
-                <a:solidFill>
-                  <a:srgbClr val="2B2318"/>
+              <a:rPr lang="en-US" sz="1200" dirty="0">
+                <a:solidFill>
+                  <a:srgbClr val="5A5044"/>
                 </a:solidFill>
                 <a:latin typeface="Calibri" pitchFamily="34" charset="0"/>
                 <a:ea typeface="Calibri" pitchFamily="34" charset="-122"/>
                 <a:cs typeface="Calibri" pitchFamily="34" charset="-120"/>
               </a:rPr>
-              <a:t>die Klassen 1–3 können in den Rat gewählt werden</a:t>
-            </a:r>
-            <a:endParaRPr lang="en-US" sz="1150" dirty="0"/>
-          </a:p>
-        </p:txBody>
-      </p:sp>
-      <p:sp>
-        <p:nvSpPr>
-          <p:cNvPr id="12" name="Text 9"/>
-          <p:cNvSpPr txBox="1"/>
-          <p:nvPr/>
-        </p:nvSpPr>
-        <p:spPr>
-          <a:xfrm>
-            <a:off x="5166360" y="2752344"/>
-            <a:ext cx="329184" cy="329184"/>
-          </a:xfrm>
-          <a:prstGeom prst="ellipse">
-            <a:avLst/>
-          </a:prstGeom>
-          <a:solidFill>
-            <a:srgbClr val="AD4426"/>
-          </a:solidFill>
-          <a:ln/>
-        </p:spPr>
-        <p:txBody>
-          <a:bodyPr wrap="square" lIns="0" tIns="0" rIns="0" bIns="0" rtlCol="0" anchor="ctr"/>
-          <a:lstStyle/>
-          <a:p>
-            <a:pPr algn="ctr" indent="0" marL="0">
-              <a:buNone/>
-            </a:pPr>
-            <a:r>
-              <a:rPr lang="en-US" sz="1200" b="1" dirty="0">
-                <a:solidFill>
-                  <a:srgbClr val="FFFFFF"/>
-                </a:solidFill>
-                <a:latin typeface="Cambria" pitchFamily="34" charset="0"/>
-                <a:ea typeface="Cambria" pitchFamily="34" charset="-122"/>
-                <a:cs typeface="Cambria" pitchFamily="34" charset="-120"/>
-              </a:rPr>
-              <a:t>3</a:t>
+              <a:t>alles – auch Archont</a:t>
             </a:r>
             <a:endParaRPr lang="en-US" sz="1200" dirty="0"/>
           </a:p>
@@ -18318,14 +18195,14 @@
       </p:sp>
       <p:sp>
         <p:nvSpPr>
-          <p:cNvPr id="13" name="Text 10"/>
-          <p:cNvSpPr txBox="1"/>
-          <p:nvPr/>
-        </p:nvSpPr>
-        <p:spPr>
-          <a:xfrm>
-            <a:off x="5577840" y="2724912"/>
-            <a:ext cx="3017520" cy="457200"/>
+          <p:cNvPr id="10" name="Text 7"/>
+          <p:cNvSpPr txBox="1"/>
+          <p:nvPr/>
+        </p:nvSpPr>
+        <p:spPr>
+          <a:xfrm>
+            <a:off x="5669280" y="2212848"/>
+            <a:ext cx="2926080" cy="256032"/>
           </a:xfrm>
           <a:prstGeom prst="rect">
             <a:avLst/>
@@ -18334,14 +18211,14 @@
           <a:ln/>
         </p:spPr>
         <p:txBody>
-          <a:bodyPr wrap="square" lIns="0" tIns="0" rIns="0" bIns="0" rtlCol="0" anchor="ctr"/>
+          <a:bodyPr wrap="square" lIns="0" tIns="0" rIns="0" bIns="0" rtlCol="0" anchor="t"/>
           <a:lstStyle/>
           <a:p>
             <a:pPr indent="0" marL="0">
               <a:buNone/>
             </a:pPr>
             <a:r>
-              <a:rPr lang="en-US" sz="1150" dirty="0">
+              <a:rPr lang="en-US" sz="1200" b="1" dirty="0">
                 <a:solidFill>
                   <a:srgbClr val="2B2318"/>
                 </a:solidFill>
@@ -18349,48 +18226,7 @@
                 <a:ea typeface="Calibri" pitchFamily="34" charset="-122"/>
                 <a:cs typeface="Calibri" pitchFamily="34" charset="-120"/>
               </a:rPr>
-              <a:t>ehemalige Archonten werden Mitglied im Areopag</a:t>
-            </a:r>
-            <a:endParaRPr lang="en-US" sz="1150" dirty="0"/>
-          </a:p>
-        </p:txBody>
-      </p:sp>
-      <p:sp>
-        <p:nvSpPr>
-          <p:cNvPr id="14" name="Text 11"/>
-          <p:cNvSpPr txBox="1"/>
-          <p:nvPr/>
-        </p:nvSpPr>
-        <p:spPr>
-          <a:xfrm>
-            <a:off x="5166360" y="3282696"/>
-            <a:ext cx="329184" cy="329184"/>
-          </a:xfrm>
-          <a:prstGeom prst="ellipse">
-            <a:avLst/>
-          </a:prstGeom>
-          <a:solidFill>
-            <a:srgbClr val="AD4426"/>
-          </a:solidFill>
-          <a:ln/>
-        </p:spPr>
-        <p:txBody>
-          <a:bodyPr wrap="square" lIns="0" tIns="0" rIns="0" bIns="0" rtlCol="0" anchor="ctr"/>
-          <a:lstStyle/>
-          <a:p>
-            <a:pPr algn="ctr" indent="0" marL="0">
-              <a:buNone/>
-            </a:pPr>
-            <a:r>
-              <a:rPr lang="en-US" sz="1200" b="1" dirty="0">
-                <a:solidFill>
-                  <a:srgbClr val="FFFFFF"/>
-                </a:solidFill>
-                <a:latin typeface="Cambria" pitchFamily="34" charset="0"/>
-                <a:ea typeface="Cambria" pitchFamily="34" charset="-122"/>
-                <a:cs typeface="Cambria" pitchFamily="34" charset="-120"/>
-              </a:rPr>
-              <a:t>4</a:t>
+              <a:t>2. + 3. Klasse</a:t>
             </a:r>
             <a:endParaRPr lang="en-US" sz="1200" dirty="0"/>
           </a:p>
@@ -18398,14 +18234,14 @@
       </p:sp>
       <p:sp>
         <p:nvSpPr>
-          <p:cNvPr id="15" name="Text 12"/>
-          <p:cNvSpPr txBox="1"/>
-          <p:nvPr/>
-        </p:nvSpPr>
-        <p:spPr>
-          <a:xfrm>
-            <a:off x="5577840" y="3255264"/>
-            <a:ext cx="3017520" cy="457200"/>
+          <p:cNvPr id="11" name="Text 8"/>
+          <p:cNvSpPr txBox="1"/>
+          <p:nvPr/>
+        </p:nvSpPr>
+        <p:spPr>
+          <a:xfrm>
+            <a:off x="5669280" y="2450592"/>
+            <a:ext cx="2926080" cy="274320"/>
           </a:xfrm>
           <a:prstGeom prst="rect">
             <a:avLst/>
@@ -18414,63 +18250,22 @@
           <a:ln/>
         </p:spPr>
         <p:txBody>
-          <a:bodyPr wrap="square" lIns="0" tIns="0" rIns="0" bIns="0" rtlCol="0" anchor="ctr"/>
+          <a:bodyPr wrap="square" lIns="0" tIns="0" rIns="0" bIns="0" rtlCol="0" anchor="t"/>
           <a:lstStyle/>
           <a:p>
             <a:pPr indent="0" marL="0">
               <a:buNone/>
             </a:pPr>
             <a:r>
-              <a:rPr lang="en-US" sz="1150" dirty="0">
-                <a:solidFill>
-                  <a:srgbClr val="2B2318"/>
+              <a:rPr lang="en-US" sz="1200" dirty="0">
+                <a:solidFill>
+                  <a:srgbClr val="5A5044"/>
                 </a:solidFill>
                 <a:latin typeface="Calibri" pitchFamily="34" charset="0"/>
                 <a:ea typeface="Calibri" pitchFamily="34" charset="-122"/>
                 <a:cs typeface="Calibri" pitchFamily="34" charset="-120"/>
               </a:rPr>
-              <a:t>die Volksversammlung wählt die Beamten</a:t>
-            </a:r>
-            <a:endParaRPr lang="en-US" sz="1150" dirty="0"/>
-          </a:p>
-        </p:txBody>
-      </p:sp>
-      <p:sp>
-        <p:nvSpPr>
-          <p:cNvPr id="16" name="Text 13"/>
-          <p:cNvSpPr txBox="1"/>
-          <p:nvPr/>
-        </p:nvSpPr>
-        <p:spPr>
-          <a:xfrm>
-            <a:off x="5166360" y="3813048"/>
-            <a:ext cx="329184" cy="329184"/>
-          </a:xfrm>
-          <a:prstGeom prst="ellipse">
-            <a:avLst/>
-          </a:prstGeom>
-          <a:solidFill>
-            <a:srgbClr val="AD4426"/>
-          </a:solidFill>
-          <a:ln/>
-        </p:spPr>
-        <p:txBody>
-          <a:bodyPr wrap="square" lIns="0" tIns="0" rIns="0" bIns="0" rtlCol="0" anchor="ctr"/>
-          <a:lstStyle/>
-          <a:p>
-            <a:pPr algn="ctr" indent="0" marL="0">
-              <a:buNone/>
-            </a:pPr>
-            <a:r>
-              <a:rPr lang="en-US" sz="1200" b="1" dirty="0">
-                <a:solidFill>
-                  <a:srgbClr val="FFFFFF"/>
-                </a:solidFill>
-                <a:latin typeface="Cambria" pitchFamily="34" charset="0"/>
-                <a:ea typeface="Cambria" pitchFamily="34" charset="-122"/>
-                <a:cs typeface="Cambria" pitchFamily="34" charset="-120"/>
-              </a:rPr>
-              <a:t>5</a:t>
+              <a:t>in den Rat, aber nicht Archont</a:t>
             </a:r>
             <a:endParaRPr lang="en-US" sz="1200" dirty="0"/>
           </a:p>
@@ -18478,14 +18273,14 @@
       </p:sp>
       <p:sp>
         <p:nvSpPr>
-          <p:cNvPr id="17" name="Text 14"/>
-          <p:cNvSpPr txBox="1"/>
-          <p:nvPr/>
-        </p:nvSpPr>
-        <p:spPr>
-          <a:xfrm>
-            <a:off x="5577840" y="3785616"/>
-            <a:ext cx="3017520" cy="457200"/>
+          <p:cNvPr id="12" name="Text 9"/>
+          <p:cNvSpPr txBox="1"/>
+          <p:nvPr/>
+        </p:nvSpPr>
+        <p:spPr>
+          <a:xfrm>
+            <a:off x="5669280" y="2779776"/>
+            <a:ext cx="2926080" cy="256032"/>
           </a:xfrm>
           <a:prstGeom prst="rect">
             <a:avLst/>
@@ -18494,14 +18289,14 @@
           <a:ln/>
         </p:spPr>
         <p:txBody>
-          <a:bodyPr wrap="square" lIns="0" tIns="0" rIns="0" bIns="0" rtlCol="0" anchor="ctr"/>
+          <a:bodyPr wrap="square" lIns="0" tIns="0" rIns="0" bIns="0" rtlCol="0" anchor="t"/>
           <a:lstStyle/>
           <a:p>
             <a:pPr indent="0" marL="0">
               <a:buNone/>
             </a:pPr>
             <a:r>
-              <a:rPr lang="en-US" sz="1150" dirty="0">
+              <a:rPr lang="en-US" sz="1200" b="1" dirty="0">
                 <a:solidFill>
                   <a:srgbClr val="2B2318"/>
                 </a:solidFill>
@@ -18509,22 +18304,22 @@
                 <a:ea typeface="Calibri" pitchFamily="34" charset="-122"/>
                 <a:cs typeface="Calibri" pitchFamily="34" charset="-120"/>
               </a:rPr>
-              <a:t>der Rat der 400 bereitet die Gesetze vor</a:t>
-            </a:r>
-            <a:endParaRPr lang="en-US" sz="1150" dirty="0"/>
-          </a:p>
-        </p:txBody>
-      </p:sp>
-      <p:sp>
-        <p:nvSpPr>
-          <p:cNvPr id="18" name="Text 15"/>
-          <p:cNvSpPr txBox="1"/>
-          <p:nvPr/>
-        </p:nvSpPr>
-        <p:spPr>
-          <a:xfrm>
-            <a:off x="457200" y="4462272"/>
-            <a:ext cx="4114800" cy="228600"/>
+              <a:t>Theten</a:t>
+            </a:r>
+            <a:endParaRPr lang="en-US" sz="1200" dirty="0"/>
+          </a:p>
+        </p:txBody>
+      </p:sp>
+      <p:sp>
+        <p:nvSpPr>
+          <p:cNvPr id="13" name="Text 10"/>
+          <p:cNvSpPr txBox="1"/>
+          <p:nvPr/>
+        </p:nvSpPr>
+        <p:spPr>
+          <a:xfrm>
+            <a:off x="5669280" y="3017520"/>
+            <a:ext cx="2926080" cy="274320"/>
           </a:xfrm>
           <a:prstGeom prst="rect">
             <a:avLst/>
@@ -18540,7 +18335,7 @@
               <a:buNone/>
             </a:pPr>
             <a:r>
-              <a:rPr lang="en-US" sz="1100" b="1" dirty="0">
+              <a:rPr lang="en-US" sz="1200" dirty="0">
                 <a:solidFill>
                   <a:srgbClr val="5A5044"/>
                 </a:solidFill>
@@ -18548,22 +18343,22 @@
                 <a:ea typeface="Calibri" pitchFamily="34" charset="-122"/>
                 <a:cs typeface="Calibri" pitchFamily="34" charset="-120"/>
               </a:rPr>
-              <a:t>Lykon: grün = darf, rot = darf nicht</a:t>
-            </a:r>
-            <a:endParaRPr lang="en-US" sz="1100" dirty="0"/>
-          </a:p>
-        </p:txBody>
-      </p:sp>
-      <p:sp>
-        <p:nvSpPr>
-          <p:cNvPr id="19" name="Text 16"/>
-          <p:cNvSpPr txBox="1"/>
-          <p:nvPr/>
-        </p:nvSpPr>
-        <p:spPr>
-          <a:xfrm>
-            <a:off x="457200" y="4754880"/>
-            <a:ext cx="4572000" cy="182880"/>
+              <a:t>nur abstimmen und klagen</a:t>
+            </a:r>
+            <a:endParaRPr lang="en-US" sz="1200" dirty="0"/>
+          </a:p>
+        </p:txBody>
+      </p:sp>
+      <p:sp>
+        <p:nvSpPr>
+          <p:cNvPr id="14" name="Text 11"/>
+          <p:cNvSpPr txBox="1"/>
+          <p:nvPr/>
+        </p:nvSpPr>
+        <p:spPr>
+          <a:xfrm>
+            <a:off x="5669280" y="3346704"/>
+            <a:ext cx="2926080" cy="256032"/>
           </a:xfrm>
           <a:prstGeom prst="rect">
             <a:avLst/>
@@ -18579,14 +18374,131 @@
               <a:buNone/>
             </a:pPr>
             <a:r>
-              <a:rPr lang="en-US" sz="900" dirty="0">
-                <a:solidFill>
-                  <a:srgbClr val="998C77"/>
+              <a:rPr lang="en-US" sz="1200" b="1" dirty="0">
+                <a:solidFill>
+                  <a:srgbClr val="2B2318"/>
                 </a:solidFill>
                 <a:latin typeface="Calibri" pitchFamily="34" charset="0"/>
                 <a:ea typeface="Calibri" pitchFamily="34" charset="-122"/>
                 <a:cs typeface="Calibri" pitchFamily="34" charset="-120"/>
               </a:rPr>
+              <a:t>Frauen, Sklaven, Fremde</a:t>
+            </a:r>
+            <a:endParaRPr lang="en-US" sz="1200" dirty="0"/>
+          </a:p>
+        </p:txBody>
+      </p:sp>
+      <p:sp>
+        <p:nvSpPr>
+          <p:cNvPr id="15" name="Text 12"/>
+          <p:cNvSpPr txBox="1"/>
+          <p:nvPr/>
+        </p:nvSpPr>
+        <p:spPr>
+          <a:xfrm>
+            <a:off x="5669280" y="3584448"/>
+            <a:ext cx="2926080" cy="274320"/>
+          </a:xfrm>
+          <a:prstGeom prst="rect">
+            <a:avLst/>
+          </a:prstGeom>
+          <a:noFill/>
+          <a:ln/>
+        </p:spPr>
+        <p:txBody>
+          <a:bodyPr wrap="square" lIns="0" tIns="0" rIns="0" bIns="0" rtlCol="0" anchor="t"/>
+          <a:lstStyle/>
+          <a:p>
+            <a:pPr indent="0" marL="0">
+              <a:buNone/>
+            </a:pPr>
+            <a:r>
+              <a:rPr lang="en-US" sz="1200" dirty="0">
+                <a:solidFill>
+                  <a:srgbClr val="5A5044"/>
+                </a:solidFill>
+                <a:latin typeface="Calibri" pitchFamily="34" charset="0"/>
+                <a:ea typeface="Calibri" pitchFamily="34" charset="-122"/>
+                <a:cs typeface="Calibri" pitchFamily="34" charset="-120"/>
+              </a:rPr>
+              <a:t>gar nichts</a:t>
+            </a:r>
+            <a:endParaRPr lang="en-US" sz="1200" dirty="0"/>
+          </a:p>
+        </p:txBody>
+      </p:sp>
+      <p:sp>
+        <p:nvSpPr>
+          <p:cNvPr id="16" name="Text 13"/>
+          <p:cNvSpPr txBox="1"/>
+          <p:nvPr/>
+        </p:nvSpPr>
+        <p:spPr>
+          <a:xfrm>
+            <a:off x="5669280" y="3950208"/>
+            <a:ext cx="2926080" cy="365760"/>
+          </a:xfrm>
+          <a:prstGeom prst="rect">
+            <a:avLst/>
+          </a:prstGeom>
+          <a:noFill/>
+          <a:ln/>
+        </p:spPr>
+        <p:txBody>
+          <a:bodyPr wrap="square" lIns="0" tIns="0" rIns="0" bIns="0" rtlCol="0" anchor="t"/>
+          <a:lstStyle/>
+          <a:p>
+            <a:pPr indent="0" marL="0">
+              <a:buNone/>
+            </a:pPr>
+            <a:r>
+              <a:rPr lang="en-US" sz="1250" b="1" dirty="0">
+                <a:solidFill>
+                  <a:srgbClr val="AD4426"/>
+                </a:solidFill>
+                <a:latin typeface="Calibri" pitchFamily="34" charset="0"/>
+                <a:ea typeface="Calibri" pitchFamily="34" charset="-122"/>
+                <a:cs typeface="Calibri" pitchFamily="34" charset="-120"/>
+              </a:rPr>
+              <a:t>Je mehr Besitz, desto mehr Rechte.</a:t>
+            </a:r>
+            <a:endParaRPr lang="en-US" sz="1250" dirty="0"/>
+          </a:p>
+        </p:txBody>
+      </p:sp>
+      <p:sp>
+        <p:nvSpPr>
+          <p:cNvPr id="17" name="Text 14"/>
+          <p:cNvSpPr txBox="1"/>
+          <p:nvPr/>
+        </p:nvSpPr>
+        <p:spPr>
+          <a:xfrm>
+            <a:off x="457200" y="4754880"/>
+            <a:ext cx="4572000" cy="182880"/>
+          </a:xfrm>
+          <a:prstGeom prst="rect">
+            <a:avLst/>
+          </a:prstGeom>
+          <a:noFill/>
+          <a:ln/>
+        </p:spPr>
+        <p:txBody>
+          <a:bodyPr wrap="square" lIns="0" tIns="0" rIns="0" bIns="0" rtlCol="0" anchor="t"/>
+          <a:lstStyle/>
+          <a:p>
+            <a:pPr indent="0" marL="0">
+              <a:buNone/>
+            </a:pPr>
+            <a:r>
+              <a:rPr lang="en-US" sz="900" dirty="0">
+                <a:solidFill>
+                  <a:srgbClr val="998C77"/>
+                </a:solidFill>
+                <a:latin typeface="Calibri" pitchFamily="34" charset="0"/>
+                <a:ea typeface="Calibri" pitchFamily="34" charset="-122"/>
+                <a:cs typeface="Calibri" pitchFamily="34" charset="-120"/>
+              </a:rPr>
               <a:t>Bürgeramt Athen</a:t>
             </a:r>
             <a:endParaRPr lang="en-US" sz="900" dirty="0"/>
@@ -18595,7 +18507,7 @@
       </p:sp>
       <p:sp>
         <p:nvSpPr>
-          <p:cNvPr id="20" name="Text 17"/>
+          <p:cNvPr id="18" name="Text 15"/>
           <p:cNvSpPr txBox="1"/>
           <p:nvPr/>
         </p:nvSpPr>

</xml_diff>

<commit_message>
Bürgeramt Athen: neue Werturteilsfrage „Eine Verfassung für alle Bürger?“
Co-Authored-By: Claude Opus 5.5 <noreply@anthropic.com>
Claude-Session: https://claude.ai/code/session_013iN4Tiarea1J9YUJHZ9iqC
</commit_message>
<xml_diff>
--- a/Geschichte_11/Stunde_Buergeramt_Athen/Folien_Buergeramt_Athen.pptx
+++ b/Geschichte_11/Stunde_Buergeramt_Athen/Folien_Buergeramt_Athen.pptx
@@ -5807,7 +5807,7 @@
               <a:buNone/>
             </a:pPr>
             <a:r>
-              <a:rPr lang="en-US" sz="2100" b="1" dirty="0">
+              <a:rPr lang="en-US" sz="2000" b="1" dirty="0">
                 <a:solidFill>
                   <a:srgbClr val="FFFFFF"/>
                 </a:solidFill>
@@ -5815,9 +5815,9 @@
                 <a:ea typeface="Cambria" pitchFamily="34" charset="-122"/>
                 <a:cs typeface="Cambria" pitchFamily="34" charset="-120"/>
               </a:rPr>
-              <a:t>Ist es gerecht, dass die Ämter vom Besitz abhängen?</a:t>
-            </a:r>
-            <a:endParaRPr lang="en-US" sz="2100" dirty="0"/>
+              <a:t>Solons Verfassungsreform – eine Verfassung für alle Bürger?</a:t>
+            </a:r>
+            <a:endParaRPr lang="en-US" sz="2000" dirty="0"/>
           </a:p>
         </p:txBody>
       </p:sp>
@@ -6598,7 +6598,7 @@
                 <a:ea typeface="Calibri" pitchFamily="34" charset="-122"/>
                 <a:cs typeface="Calibri" pitchFamily="34" charset="-120"/>
               </a:rPr>
-              <a:t>Schreibe 2–3 Sätze: „Gemessen an … halte ich es für gerecht / teilweise gerecht / nicht gerecht, weil …“</a:t>
+              <a:t>Schreibe 2–3 Sätze: „Gemessen an … halte ich Solons Verfassung für eine / nur teilweise eine / keine Verfassung für alle Bürger, weil …“</a:t>
             </a:r>
             <a:endParaRPr lang="en-US" sz="1250" dirty="0"/>
           </a:p>
@@ -7820,7 +7820,7 @@
                 <a:ea typeface="Calibri" pitchFamily="34" charset="-122"/>
                 <a:cs typeface="Calibri" pitchFamily="34" charset="-120"/>
               </a:rPr>
-              <a:t>„Gemessen an der Gleichheit aller Bürger halte ich es für nicht gerecht, dass die Ämter vom Besitz abhingen, weil arme Bürger wie Lykon (Anliegen 1) nie selbst regieren konnten.“</a:t>
+              <a:t>„Gemessen an der Gleichheit halte ich Solons Verfassung für keine Verfassung für alle Bürger, weil arme Bürger wie Lykon (Anliegen 1) zwar abstimmen, aber nie ein Amt übernehmen konnten. Frauen wie Thessale (Anliegen 6) waren ganz ausgeschlossen.“</a:t>
             </a:r>
             <a:endParaRPr lang="en-US" sz="1300" dirty="0"/>
           </a:p>
@@ -7925,7 +7925,7 @@
                 <a:ea typeface="Calibri" pitchFamily="34" charset="-122"/>
                 <a:cs typeface="Calibri" pitchFamily="34" charset="-120"/>
               </a:rPr>
-              <a:t>„Gemessen an der Leistung halte ich es für teilweise gerecht, weil die Reichen mehr Lasten trugen und man durch Besitz aufsteigen konnte wie Kallippos (Anliegen 9). Wer arm blieb, hatte aber keine Chance auf ein Amt.“</a:t>
+              <a:t>„Gemessen an der Leistung halte ich sie für teilweise eine Verfassung für alle Bürger, weil jeder durch Besitz aufsteigen konnte wie Kallippos (Anliegen 9) – die Herkunft zählte nicht mehr. Wer arm blieb, kam aber an kein Amt.“</a:t>
             </a:r>
             <a:endParaRPr lang="en-US" sz="1300" dirty="0"/>
           </a:p>

</xml_diff>